<commit_message>
Slides: sd-01-002 and sd-01-008 get their check question slide
Their slide 9 was a recap, so the PPTX of both lacked the check question and
its answer that docs/sd101-slides.md asks for. Slide 9 of each deck on Moda now
holds the question and answer of the lesson's ## Nhìn hình trả lời section, and
both PPTX are exported again (10 slides, badge on every slide).

Co-Authored-By: Claude Sonnet 5.5 <noreply@anthropic.com>
Claude-Session: https://claude.ai/code/session_017C4f48Zx2kwKGX2QXzdhks
</commit_message>
<xml_diff>
--- a/system-design-101/vi/lessons/sd-01-002/slides/sd-01-002.pptx
+++ b/system-design-101/vi/lessons/sd-01-002/slides/sd-01-002.pptx
@@ -17821,1661 +17821,7 @@
       </p:grpSpPr>
       <p:sp>
         <p:nvSpPr>
-          <p:cNvPr id="2" name="Text 0"/>
-          <p:cNvSpPr/>
-          <p:nvPr/>
-        </p:nvSpPr>
-        <p:spPr>
-          <a:xfrm>
-            <a:off x="914400" y="952500"/>
-            <a:ext cx="8572500" cy="323850"/>
-          </a:xfrm>
-          <a:prstGeom prst="rect">
-            <a:avLst/>
-          </a:prstGeom>
-          <a:noFill/>
-          <a:ln/>
-        </p:spPr>
-        <p:txBody>
-          <a:bodyPr wrap="square" lIns="0" tIns="0" rIns="0" bIns="0" rtlCol="0" anchor="t"/>
-          <a:lstStyle/>
-          <a:p>
-            <a:pPr algn="l" indent="0" marL="0">
-              <a:buNone/>
-            </a:pPr>
-            <a:r>
-              <a:rPr lang="en-US" sz="1800" b="1" spc="272" kern="0" dirty="0">
-                <a:solidFill>
-                  <a:srgbClr val="6B6A66"/>
-                </a:solidFill>
-                <a:latin typeface="Be Vietnam Pro" pitchFamily="34" charset="0"/>
-                <a:ea typeface="Be Vietnam Pro" pitchFamily="34" charset="-122"/>
-                <a:cs typeface="Be Vietnam Pro" pitchFamily="34" charset="-120"/>
-              </a:rPr>
-              <a:t>TÓM</a:t>
-            </a:r>
-            <a:r>
-              <a:rPr lang="en-US" sz="1800" b="1" spc="208" kern="0" dirty="0">
-                <a:solidFill>
-                  <a:srgbClr val="6B6A66"/>
-                </a:solidFill>
-                <a:latin typeface="Be Vietnam Pro" pitchFamily="34" charset="0"/>
-                <a:ea typeface="Be Vietnam Pro" pitchFamily="34" charset="-122"/>
-                <a:cs typeface="Be Vietnam Pro" pitchFamily="34" charset="-120"/>
-              </a:rPr>
-              <a:t> TẮT</a:t>
-            </a:r>
-            <a:endParaRPr lang="en-US" sz="1800" dirty="0"/>
-          </a:p>
-        </p:txBody>
-      </p:sp>
-      <p:sp>
-        <p:nvSpPr>
-          <p:cNvPr id="3" name="Text 1"/>
-          <p:cNvSpPr/>
-          <p:nvPr/>
-        </p:nvSpPr>
-        <p:spPr>
-          <a:xfrm>
-            <a:off x="914400" y="1333500"/>
-            <a:ext cx="16459200" cy="1066800"/>
-          </a:xfrm>
-          <a:prstGeom prst="rect">
-            <a:avLst/>
-          </a:prstGeom>
-          <a:noFill/>
-          <a:ln/>
-        </p:spPr>
-        <p:txBody>
-          <a:bodyPr wrap="square" lIns="0" tIns="59150" rIns="0" bIns="-59150" rtlCol="0" anchor="ctr"/>
-          <a:lstStyle/>
-          <a:p>
-            <a:pPr algn="l" indent="0" marL="0">
-              <a:lnSpc>
-                <a:spcPts val="7245"/>
-              </a:lnSpc>
-              <a:buNone/>
-            </a:pPr>
-            <a:r>
-              <a:rPr lang="en-US" sz="6900" dirty="0" spc="1" kern="0">
-                <a:solidFill>
-                  <a:srgbClr val="14161C"/>
-                </a:solidFill>
-                <a:latin typeface="Bricolage Grotesque ExtraBold" pitchFamily="34" charset="0"/>
-                <a:ea typeface="Bricolage Grotesque ExtraBold" pitchFamily="34" charset="-122"/>
-                <a:cs typeface="Bricolage Grotesque ExtraBold" pitchFamily="34" charset="-120"/>
-              </a:rPr>
-              <a:t>Sáu</a:t>
-            </a:r>
-            <a:r>
-              <a:rPr lang="en-US" sz="6900" dirty="0" spc="-1" kern="0">
-                <a:solidFill>
-                  <a:srgbClr val="14161C"/>
-                </a:solidFill>
-                <a:latin typeface="Bricolage Grotesque ExtraBold" pitchFamily="34" charset="0"/>
-                <a:ea typeface="Bricolage Grotesque ExtraBold" pitchFamily="34" charset="-122"/>
-                <a:cs typeface="Bricolage Grotesque ExtraBold" pitchFamily="34" charset="-120"/>
-              </a:rPr>
-              <a:t> việc của LB</a:t>
-            </a:r>
-            <a:endParaRPr lang="en-US" sz="6900" dirty="0"/>
-          </a:p>
-        </p:txBody>
-      </p:sp>
-      <p:sp>
-        <p:nvSpPr>
-          <p:cNvPr id="4" name="Shape 2"/>
-          <p:cNvSpPr/>
-          <p:nvPr/>
-        </p:nvSpPr>
-        <p:spPr>
-          <a:xfrm>
-            <a:off x="914400" y="2590800"/>
-            <a:ext cx="16459200" cy="876300"/>
-          </a:xfrm>
-          <a:prstGeom prst="roundRect">
-            <a:avLst>
-              <a:gd name="adj" fmla="val 50000"/>
-            </a:avLst>
-          </a:prstGeom>
-          <a:solidFill>
-            <a:srgbClr val="CFE8E2"/>
-          </a:solidFill>
-          <a:ln/>
-        </p:spPr>
-      </p:sp>
-      <p:sp>
-        <p:nvSpPr>
-          <p:cNvPr id="5" name="Text 3"/>
-          <p:cNvSpPr/>
-          <p:nvPr/>
-        </p:nvSpPr>
-        <p:spPr>
-          <a:xfrm>
-            <a:off x="1047750" y="2724150"/>
-            <a:ext cx="609600" cy="609600"/>
-          </a:xfrm>
-          <a:prstGeom prst="roundRect">
-            <a:avLst>
-              <a:gd name="adj" fmla="val 50000"/>
-            </a:avLst>
-          </a:prstGeom>
-          <a:solidFill>
-            <a:srgbClr val="0F766E"/>
-          </a:solidFill>
-          <a:ln/>
-        </p:spPr>
-        <p:txBody>
-          <a:bodyPr wrap="square" lIns="0" tIns="0" rIns="0" bIns="0" rtlCol="0" anchor="ctr"/>
-          <a:lstStyle/>
-          <a:p>
-            <a:pPr algn="ctr" indent="0" marL="0">
-              <a:buNone/>
-            </a:pPr>
-            <a:r>
-              <a:rPr lang="en-US" sz="3000" dirty="0" spc="5" kern="0">
-                <a:solidFill>
-                  <a:srgbClr val="FFFFFF"/>
-                </a:solidFill>
-                <a:latin typeface="Bricolage Grotesque ExtraBold" pitchFamily="34" charset="0"/>
-                <a:ea typeface="Bricolage Grotesque ExtraBold" pitchFamily="34" charset="-122"/>
-                <a:cs typeface="Bricolage Grotesque ExtraBold" pitchFamily="34" charset="-120"/>
-              </a:rPr>
-              <a:t>1</a:t>
-            </a:r>
-            <a:endParaRPr lang="en-US" sz="3000" dirty="0"/>
-          </a:p>
-        </p:txBody>
-      </p:sp>
-      <p:sp>
-        <p:nvSpPr>
-          <p:cNvPr id="6" name="Text 4"/>
-          <p:cNvSpPr/>
-          <p:nvPr/>
-        </p:nvSpPr>
-        <p:spPr>
-          <a:xfrm>
-            <a:off x="1943100" y="2590800"/>
-            <a:ext cx="4953000" cy="876300"/>
-          </a:xfrm>
-          <a:prstGeom prst="rect">
-            <a:avLst/>
-          </a:prstGeom>
-          <a:noFill/>
-          <a:ln/>
-        </p:spPr>
-        <p:txBody>
-          <a:bodyPr wrap="square" lIns="0" tIns="0" rIns="0" bIns="0" rtlCol="0" anchor="ctr"/>
-          <a:lstStyle/>
-          <a:p>
-            <a:pPr algn="l" indent="0" marL="0">
-              <a:buNone/>
-            </a:pPr>
-            <a:r>
-              <a:rPr lang="en-US" sz="2400" b="1" dirty="0" spc="-43" kern="0">
-                <a:solidFill>
-                  <a:srgbClr val="0F766E"/>
-                </a:solidFill>
-                <a:latin typeface="Be Vietnam Pro" pitchFamily="34" charset="0"/>
-                <a:ea typeface="Be Vietnam Pro" pitchFamily="34" charset="-122"/>
-                <a:cs typeface="Be Vietnam Pro" pitchFamily="34" charset="-120"/>
-              </a:rPr>
-              <a:t>Xử</a:t>
-            </a:r>
-            <a:r>
-              <a:rPr lang="en-US" sz="2400" b="1" dirty="0" spc="0" kern="0">
-                <a:solidFill>
-                  <a:srgbClr val="0F766E"/>
-                </a:solidFill>
-                <a:latin typeface="Be Vietnam Pro" pitchFamily="34" charset="0"/>
-                <a:ea typeface="Be Vietnam Pro" pitchFamily="34" charset="-122"/>
-                <a:cs typeface="Be Vietnam Pro" pitchFamily="34" charset="-120"/>
-              </a:rPr>
-              <a:t> lý</a:t>
-            </a:r>
-            <a:r>
-              <a:rPr lang="en-US" sz="2400" b="1" dirty="0" spc="-1" kern="0">
-                <a:solidFill>
-                  <a:srgbClr val="0F766E"/>
-                </a:solidFill>
-                <a:latin typeface="Be Vietnam Pro" pitchFamily="34" charset="0"/>
-                <a:ea typeface="Be Vietnam Pro" pitchFamily="34" charset="-122"/>
-                <a:cs typeface="Be Vietnam Pro" pitchFamily="34" charset="-120"/>
-              </a:rPr>
-              <a:t> lỗi</a:t>
-            </a:r>
-            <a:endParaRPr lang="en-US" sz="2400" dirty="0"/>
-          </a:p>
-        </p:txBody>
-      </p:sp>
-      <p:sp>
-        <p:nvSpPr>
-          <p:cNvPr id="7" name="Text 5"/>
-          <p:cNvSpPr/>
-          <p:nvPr/>
-        </p:nvSpPr>
-        <p:spPr>
-          <a:xfrm>
-            <a:off x="7048500" y="2590800"/>
-            <a:ext cx="10096500" cy="876300"/>
-          </a:xfrm>
-          <a:prstGeom prst="rect">
-            <a:avLst/>
-          </a:prstGeom>
-          <a:noFill/>
-          <a:ln/>
-        </p:spPr>
-        <p:txBody>
-          <a:bodyPr wrap="square" lIns="0" tIns="0" rIns="0" bIns="0" rtlCol="0" anchor="ctr"/>
-          <a:lstStyle/>
-          <a:p>
-            <a:pPr algn="l" indent="0" marL="0">
-              <a:buNone/>
-            </a:pPr>
-            <a:r>
-              <a:rPr lang="en-US" sz="2400" dirty="0" spc="-23" kern="0">
-                <a:solidFill>
-                  <a:srgbClr val="14161C"/>
-                </a:solidFill>
-                <a:latin typeface="Be Vietnam Pro" pitchFamily="34" charset="0"/>
-                <a:ea typeface="Be Vietnam Pro" pitchFamily="34" charset="-122"/>
-                <a:cs typeface="Be Vietnam Pro" pitchFamily="34" charset="-120"/>
-              </a:rPr>
-              <a:t>Request</a:t>
-            </a:r>
-            <a:r>
-              <a:rPr lang="en-US" sz="2400" dirty="0" spc="2" kern="0">
-                <a:solidFill>
-                  <a:srgbClr val="14161C"/>
-                </a:solidFill>
-                <a:latin typeface="Be Vietnam Pro" pitchFamily="34" charset="0"/>
-                <a:ea typeface="Be Vietnam Pro" pitchFamily="34" charset="-122"/>
-                <a:cs typeface="Be Vietnam Pro" pitchFamily="34" charset="-120"/>
-              </a:rPr>
-              <a:t> mới</a:t>
-            </a:r>
-            <a:r>
-              <a:rPr lang="en-US" sz="2400" dirty="0" spc="1" kern="0">
-                <a:solidFill>
-                  <a:srgbClr val="14161C"/>
-                </a:solidFill>
-                <a:latin typeface="Be Vietnam Pro" pitchFamily="34" charset="0"/>
-                <a:ea typeface="Be Vietnam Pro" pitchFamily="34" charset="-122"/>
-                <a:cs typeface="Be Vietnam Pro" pitchFamily="34" charset="-120"/>
-              </a:rPr>
-              <a:t> có</a:t>
-            </a:r>
-            <a:r>
-              <a:rPr lang="en-US" sz="2400" dirty="0" spc="0" kern="0">
-                <a:solidFill>
-                  <a:srgbClr val="14161C"/>
-                </a:solidFill>
-                <a:latin typeface="Be Vietnam Pro" pitchFamily="34" charset="0"/>
-                <a:ea typeface="Be Vietnam Pro" pitchFamily="34" charset="-122"/>
-                <a:cs typeface="Be Vietnam Pro" pitchFamily="34" charset="-120"/>
-              </a:rPr>
-              <a:t> thể</a:t>
-            </a:r>
-            <a:r>
-              <a:rPr lang="en-US" sz="2400" dirty="0" spc="32" kern="0">
-                <a:solidFill>
-                  <a:srgbClr val="14161C"/>
-                </a:solidFill>
-                <a:latin typeface="Be Vietnam Pro" pitchFamily="34" charset="0"/>
-                <a:ea typeface="Be Vietnam Pro" pitchFamily="34" charset="-122"/>
-                <a:cs typeface="Be Vietnam Pro" pitchFamily="34" charset="-120"/>
-              </a:rPr>
-              <a:t> đi</a:t>
-            </a:r>
-            <a:r>
-              <a:rPr lang="en-US" sz="2400" dirty="0" spc="-11" kern="0">
-                <a:solidFill>
-                  <a:srgbClr val="14161C"/>
-                </a:solidFill>
-                <a:latin typeface="Be Vietnam Pro" pitchFamily="34" charset="0"/>
-                <a:ea typeface="Be Vietnam Pro" pitchFamily="34" charset="-122"/>
-                <a:cs typeface="Be Vietnam Pro" pitchFamily="34" charset="-120"/>
-              </a:rPr>
-              <a:t> tới</a:t>
-            </a:r>
-            <a:r>
-              <a:rPr lang="en-US" sz="2400" dirty="0" spc="3" kern="0">
-                <a:solidFill>
-                  <a:srgbClr val="14161C"/>
-                </a:solidFill>
-                <a:latin typeface="Be Vietnam Pro" pitchFamily="34" charset="0"/>
-                <a:ea typeface="Be Vietnam Pro" pitchFamily="34" charset="-122"/>
-                <a:cs typeface="Be Vietnam Pro" pitchFamily="34" charset="-120"/>
-              </a:rPr>
-              <a:t> B</a:t>
-            </a:r>
-            <a:r>
-              <a:rPr lang="en-US" sz="2400" dirty="0" spc="0" kern="0">
-                <a:solidFill>
-                  <a:srgbClr val="14161C"/>
-                </a:solidFill>
-                <a:latin typeface="Be Vietnam Pro" pitchFamily="34" charset="0"/>
-                <a:ea typeface="Be Vietnam Pro" pitchFamily="34" charset="-122"/>
-                <a:cs typeface="Be Vietnam Pro" pitchFamily="34" charset="-120"/>
-              </a:rPr>
-              <a:t> còn</a:t>
-            </a:r>
-            <a:r>
-              <a:rPr lang="en-US" sz="2400" dirty="0" spc="-2" kern="0">
-                <a:solidFill>
-                  <a:srgbClr val="14161C"/>
-                </a:solidFill>
-                <a:latin typeface="Be Vietnam Pro" pitchFamily="34" charset="0"/>
-                <a:ea typeface="Be Vietnam Pro" pitchFamily="34" charset="-122"/>
-                <a:cs typeface="Be Vietnam Pro" pitchFamily="34" charset="-120"/>
-              </a:rPr>
-              <a:t> khỏe.</a:t>
-            </a:r>
-            <a:endParaRPr lang="en-US" sz="2400" dirty="0"/>
-          </a:p>
-        </p:txBody>
-      </p:sp>
-      <p:sp>
-        <p:nvSpPr>
-          <p:cNvPr id="8" name="Shape 6"/>
-          <p:cNvSpPr/>
-          <p:nvPr/>
-        </p:nvSpPr>
-        <p:spPr>
-          <a:xfrm>
-            <a:off x="914400" y="3581400"/>
-            <a:ext cx="16459200" cy="876300"/>
-          </a:xfrm>
-          <a:prstGeom prst="roundRect">
-            <a:avLst>
-              <a:gd name="adj" fmla="val 50000"/>
-            </a:avLst>
-          </a:prstGeom>
-          <a:solidFill>
-            <a:srgbClr val="F8D9D0"/>
-          </a:solidFill>
-          <a:ln/>
-        </p:spPr>
-      </p:sp>
-      <p:sp>
-        <p:nvSpPr>
-          <p:cNvPr id="9" name="Text 7"/>
-          <p:cNvSpPr/>
-          <p:nvPr/>
-        </p:nvSpPr>
-        <p:spPr>
-          <a:xfrm>
-            <a:off x="1047750" y="3714750"/>
-            <a:ext cx="609600" cy="609600"/>
-          </a:xfrm>
-          <a:prstGeom prst="roundRect">
-            <a:avLst>
-              <a:gd name="adj" fmla="val 50000"/>
-            </a:avLst>
-          </a:prstGeom>
-          <a:solidFill>
-            <a:srgbClr val="E8472B"/>
-          </a:solidFill>
-          <a:ln/>
-        </p:spPr>
-        <p:txBody>
-          <a:bodyPr wrap="square" lIns="0" tIns="0" rIns="0" bIns="0" rtlCol="0" anchor="ctr"/>
-          <a:lstStyle/>
-          <a:p>
-            <a:pPr algn="ctr" indent="0" marL="0">
-              <a:buNone/>
-            </a:pPr>
-            <a:r>
-              <a:rPr lang="en-US" sz="3000" dirty="0" spc="3" kern="0">
-                <a:solidFill>
-                  <a:srgbClr val="FFFFFF"/>
-                </a:solidFill>
-                <a:latin typeface="Bricolage Grotesque ExtraBold" pitchFamily="34" charset="0"/>
-                <a:ea typeface="Bricolage Grotesque ExtraBold" pitchFamily="34" charset="-122"/>
-                <a:cs typeface="Bricolage Grotesque ExtraBold" pitchFamily="34" charset="-120"/>
-              </a:rPr>
-              <a:t>2</a:t>
-            </a:r>
-            <a:endParaRPr lang="en-US" sz="3000" dirty="0"/>
-          </a:p>
-        </p:txBody>
-      </p:sp>
-      <p:sp>
-        <p:nvSpPr>
-          <p:cNvPr id="10" name="Text 8"/>
-          <p:cNvSpPr/>
-          <p:nvPr/>
-        </p:nvSpPr>
-        <p:spPr>
-          <a:xfrm>
-            <a:off x="1943100" y="3581400"/>
-            <a:ext cx="4953000" cy="876300"/>
-          </a:xfrm>
-          <a:prstGeom prst="rect">
-            <a:avLst/>
-          </a:prstGeom>
-          <a:noFill/>
-          <a:ln/>
-        </p:spPr>
-        <p:txBody>
-          <a:bodyPr wrap="square" lIns="0" tIns="0" rIns="0" bIns="0" rtlCol="0" anchor="ctr"/>
-          <a:lstStyle/>
-          <a:p>
-            <a:pPr algn="l" indent="0" marL="0">
-              <a:buNone/>
-            </a:pPr>
-            <a:r>
-              <a:rPr lang="en-US" sz="2400" b="1" dirty="0" spc="-4" kern="0">
-                <a:solidFill>
-                  <a:srgbClr val="E8472B"/>
-                </a:solidFill>
-                <a:latin typeface="Be Vietnam Pro" pitchFamily="34" charset="0"/>
-                <a:ea typeface="Be Vietnam Pro" pitchFamily="34" charset="-122"/>
-                <a:cs typeface="Be Vietnam Pro" pitchFamily="34" charset="-120"/>
-              </a:rPr>
-              <a:t>Kiểm</a:t>
-            </a:r>
-            <a:r>
-              <a:rPr lang="en-US" sz="2400" b="1" dirty="0" spc="-10" kern="0">
-                <a:solidFill>
-                  <a:srgbClr val="E8472B"/>
-                </a:solidFill>
-                <a:latin typeface="Be Vietnam Pro" pitchFamily="34" charset="0"/>
-                <a:ea typeface="Be Vietnam Pro" pitchFamily="34" charset="-122"/>
-                <a:cs typeface="Be Vietnam Pro" pitchFamily="34" charset="-120"/>
-              </a:rPr>
-              <a:t> tra</a:t>
-            </a:r>
-            <a:r>
-              <a:rPr lang="en-US" sz="2400" b="1" dirty="0" spc="14" kern="0">
-                <a:solidFill>
-                  <a:srgbClr val="E8472B"/>
-                </a:solidFill>
-                <a:latin typeface="Be Vietnam Pro" pitchFamily="34" charset="0"/>
-                <a:ea typeface="Be Vietnam Pro" pitchFamily="34" charset="-122"/>
-                <a:cs typeface="Be Vietnam Pro" pitchFamily="34" charset="-120"/>
-              </a:rPr>
-              <a:t> sức</a:t>
-            </a:r>
-            <a:r>
-              <a:rPr lang="en-US" sz="2400" b="1" dirty="0" spc="-5" kern="0">
-                <a:solidFill>
-                  <a:srgbClr val="E8472B"/>
-                </a:solidFill>
-                <a:latin typeface="Be Vietnam Pro" pitchFamily="34" charset="0"/>
-                <a:ea typeface="Be Vietnam Pro" pitchFamily="34" charset="-122"/>
-                <a:cs typeface="Be Vietnam Pro" pitchFamily="34" charset="-120"/>
-              </a:rPr>
-              <a:t> khỏe</a:t>
-            </a:r>
-            <a:endParaRPr lang="en-US" sz="2400" dirty="0"/>
-          </a:p>
-        </p:txBody>
-      </p:sp>
-      <p:sp>
-        <p:nvSpPr>
-          <p:cNvPr id="11" name="Text 9"/>
-          <p:cNvSpPr/>
-          <p:nvPr/>
-        </p:nvSpPr>
-        <p:spPr>
-          <a:xfrm>
-            <a:off x="7048500" y="3581400"/>
-            <a:ext cx="10096500" cy="876300"/>
-          </a:xfrm>
-          <a:prstGeom prst="rect">
-            <a:avLst/>
-          </a:prstGeom>
-          <a:noFill/>
-          <a:ln/>
-        </p:spPr>
-        <p:txBody>
-          <a:bodyPr wrap="square" lIns="0" tIns="0" rIns="0" bIns="0" rtlCol="0" anchor="ctr"/>
-          <a:lstStyle/>
-          <a:p>
-            <a:pPr algn="l" indent="0" marL="0">
-              <a:buNone/>
-            </a:pPr>
-            <a:r>
-              <a:rPr lang="en-US" sz="2400" dirty="0" spc="-46" kern="0">
-                <a:solidFill>
-                  <a:srgbClr val="14161C"/>
-                </a:solidFill>
-                <a:latin typeface="Be Vietnam Pro" pitchFamily="34" charset="0"/>
-                <a:ea typeface="Be Vietnam Pro" pitchFamily="34" charset="-122"/>
-                <a:cs typeface="Be Vietnam Pro" pitchFamily="34" charset="-120"/>
-              </a:rPr>
-              <a:t>Kết</a:t>
-            </a:r>
-            <a:r>
-              <a:rPr lang="en-US" sz="2400" dirty="0" spc="1" kern="0">
-                <a:solidFill>
-                  <a:srgbClr val="14161C"/>
-                </a:solidFill>
-                <a:latin typeface="Be Vietnam Pro" pitchFamily="34" charset="0"/>
-                <a:ea typeface="Be Vietnam Pro" pitchFamily="34" charset="-122"/>
-                <a:cs typeface="Be Vietnam Pro" pitchFamily="34" charset="-120"/>
-              </a:rPr>
-              <a:t> quả</a:t>
-            </a:r>
-            <a:r>
-              <a:rPr lang="en-US" sz="2400" dirty="0" spc="3" kern="0">
-                <a:solidFill>
-                  <a:srgbClr val="14161C"/>
-                </a:solidFill>
-                <a:latin typeface="Be Vietnam Pro" pitchFamily="34" charset="0"/>
-                <a:ea typeface="Be Vietnam Pro" pitchFamily="34" charset="-122"/>
-                <a:cs typeface="Be Vietnam Pro" pitchFamily="34" charset="-120"/>
-              </a:rPr>
-              <a:t> giúp</a:t>
-            </a:r>
-            <a:r>
-              <a:rPr lang="en-US" sz="2400" dirty="0" spc="-18" kern="0">
-                <a:solidFill>
-                  <a:srgbClr val="14161C"/>
-                </a:solidFill>
-                <a:latin typeface="Be Vietnam Pro" pitchFamily="34" charset="0"/>
-                <a:ea typeface="Be Vietnam Pro" pitchFamily="34" charset="-122"/>
-                <a:cs typeface="Be Vietnam Pro" pitchFamily="34" charset="-120"/>
-              </a:rPr>
-              <a:t> quyết</a:t>
-            </a:r>
-            <a:r>
-              <a:rPr lang="en-US" sz="2400" dirty="0" spc="19" kern="0">
-                <a:solidFill>
-                  <a:srgbClr val="14161C"/>
-                </a:solidFill>
-                <a:latin typeface="Be Vietnam Pro" pitchFamily="34" charset="0"/>
-                <a:ea typeface="Be Vietnam Pro" pitchFamily="34" charset="-122"/>
-                <a:cs typeface="Be Vietnam Pro" pitchFamily="34" charset="-120"/>
-              </a:rPr>
-              <a:t> định</a:t>
-            </a:r>
-            <a:r>
-              <a:rPr lang="en-US" sz="2400" dirty="0" spc="-6" kern="0">
-                <a:solidFill>
-                  <a:srgbClr val="14161C"/>
-                </a:solidFill>
-                <a:latin typeface="Be Vietnam Pro" pitchFamily="34" charset="0"/>
-                <a:ea typeface="Be Vietnam Pro" pitchFamily="34" charset="-122"/>
-                <a:cs typeface="Be Vietnam Pro" pitchFamily="34" charset="-120"/>
-              </a:rPr>
-              <a:t> máy</a:t>
-            </a:r>
-            <a:r>
-              <a:rPr lang="en-US" sz="2400" dirty="0" spc="3" kern="0">
-                <a:solidFill>
-                  <a:srgbClr val="14161C"/>
-                </a:solidFill>
-                <a:latin typeface="Be Vietnam Pro" pitchFamily="34" charset="0"/>
-                <a:ea typeface="Be Vietnam Pro" pitchFamily="34" charset="-122"/>
-                <a:cs typeface="Be Vietnam Pro" pitchFamily="34" charset="-120"/>
-              </a:rPr>
-              <a:t> nào</a:t>
-            </a:r>
-            <a:r>
-              <a:rPr lang="en-US" sz="2400" dirty="0" spc="1" kern="0">
-                <a:solidFill>
-                  <a:srgbClr val="14161C"/>
-                </a:solidFill>
-                <a:latin typeface="Be Vietnam Pro" pitchFamily="34" charset="0"/>
-                <a:ea typeface="Be Vietnam Pro" pitchFamily="34" charset="-122"/>
-                <a:cs typeface="Be Vietnam Pro" pitchFamily="34" charset="-120"/>
-              </a:rPr>
-              <a:t> nhận</a:t>
-            </a:r>
-            <a:r>
-              <a:rPr lang="en-US" sz="2400" dirty="0" spc="16" kern="0">
-                <a:solidFill>
-                  <a:srgbClr val="14161C"/>
-                </a:solidFill>
-                <a:latin typeface="Be Vietnam Pro" pitchFamily="34" charset="0"/>
-                <a:ea typeface="Be Vietnam Pro" pitchFamily="34" charset="-122"/>
-                <a:cs typeface="Be Vietnam Pro" pitchFamily="34" charset="-120"/>
-              </a:rPr>
-              <a:t> lưu</a:t>
-            </a:r>
-            <a:r>
-              <a:rPr lang="en-US" sz="2400" dirty="0" spc="6" kern="0">
-                <a:solidFill>
-                  <a:srgbClr val="14161C"/>
-                </a:solidFill>
-                <a:latin typeface="Be Vietnam Pro" pitchFamily="34" charset="0"/>
-                <a:ea typeface="Be Vietnam Pro" pitchFamily="34" charset="-122"/>
-                <a:cs typeface="Be Vietnam Pro" pitchFamily="34" charset="-120"/>
-              </a:rPr>
-              <a:t> lượng.</a:t>
-            </a:r>
-            <a:endParaRPr lang="en-US" sz="2400" dirty="0"/>
-          </a:p>
-        </p:txBody>
-      </p:sp>
-      <p:sp>
-        <p:nvSpPr>
-          <p:cNvPr id="12" name="Shape 10"/>
-          <p:cNvSpPr/>
-          <p:nvPr/>
-        </p:nvSpPr>
-        <p:spPr>
-          <a:xfrm>
-            <a:off x="914400" y="4572000"/>
-            <a:ext cx="16459200" cy="876300"/>
-          </a:xfrm>
-          <a:prstGeom prst="roundRect">
-            <a:avLst>
-              <a:gd name="adj" fmla="val 50000"/>
-            </a:avLst>
-          </a:prstGeom>
-          <a:solidFill>
-            <a:srgbClr val="DDE3FA"/>
-          </a:solidFill>
-          <a:ln/>
-        </p:spPr>
-      </p:sp>
-      <p:sp>
-        <p:nvSpPr>
-          <p:cNvPr id="13" name="Text 11"/>
-          <p:cNvSpPr/>
-          <p:nvPr/>
-        </p:nvSpPr>
-        <p:spPr>
-          <a:xfrm>
-            <a:off x="1047750" y="4705350"/>
-            <a:ext cx="609600" cy="609600"/>
-          </a:xfrm>
-          <a:prstGeom prst="roundRect">
-            <a:avLst>
-              <a:gd name="adj" fmla="val 50000"/>
-            </a:avLst>
-          </a:prstGeom>
-          <a:solidFill>
-            <a:srgbClr val="1F3FD1"/>
-          </a:solidFill>
-          <a:ln/>
-        </p:spPr>
-        <p:txBody>
-          <a:bodyPr wrap="square" lIns="0" tIns="0" rIns="0" bIns="0" rtlCol="0" anchor="ctr"/>
-          <a:lstStyle/>
-          <a:p>
-            <a:pPr algn="ctr" indent="0" marL="0">
-              <a:buNone/>
-            </a:pPr>
-            <a:r>
-              <a:rPr lang="en-US" sz="3000" dirty="0" spc="-5" kern="0">
-                <a:solidFill>
-                  <a:srgbClr val="FFFFFF"/>
-                </a:solidFill>
-                <a:latin typeface="Bricolage Grotesque ExtraBold" pitchFamily="34" charset="0"/>
-                <a:ea typeface="Bricolage Grotesque ExtraBold" pitchFamily="34" charset="-122"/>
-                <a:cs typeface="Bricolage Grotesque ExtraBold" pitchFamily="34" charset="-120"/>
-              </a:rPr>
-              <a:t>3</a:t>
-            </a:r>
-            <a:endParaRPr lang="en-US" sz="3000" dirty="0"/>
-          </a:p>
-        </p:txBody>
-      </p:sp>
-      <p:sp>
-        <p:nvSpPr>
-          <p:cNvPr id="14" name="Text 12"/>
-          <p:cNvSpPr/>
-          <p:nvPr/>
-        </p:nvSpPr>
-        <p:spPr>
-          <a:xfrm>
-            <a:off x="1943100" y="4572000"/>
-            <a:ext cx="4953000" cy="876300"/>
-          </a:xfrm>
-          <a:prstGeom prst="rect">
-            <a:avLst/>
-          </a:prstGeom>
-          <a:noFill/>
-          <a:ln/>
-        </p:spPr>
-        <p:txBody>
-          <a:bodyPr wrap="square" lIns="0" tIns="0" rIns="0" bIns="0" rtlCol="0" anchor="ctr"/>
-          <a:lstStyle/>
-          <a:p>
-            <a:pPr algn="l" indent="0" marL="0">
-              <a:buNone/>
-            </a:pPr>
-            <a:r>
-              <a:rPr lang="en-US" sz="2400" b="1" dirty="0" spc="-1" kern="0">
-                <a:solidFill>
-                  <a:srgbClr val="1F3FD1"/>
-                </a:solidFill>
-                <a:latin typeface="Be Vietnam Pro" pitchFamily="34" charset="0"/>
-                <a:ea typeface="Be Vietnam Pro" pitchFamily="34" charset="-122"/>
-                <a:cs typeface="Be Vietnam Pro" pitchFamily="34" charset="-120"/>
-              </a:rPr>
-              <a:t>Phân</a:t>
-            </a:r>
-            <a:r>
-              <a:rPr lang="en-US" sz="2400" b="1" dirty="0" spc="-5" kern="0">
-                <a:solidFill>
-                  <a:srgbClr val="1F3FD1"/>
-                </a:solidFill>
-                <a:latin typeface="Be Vietnam Pro" pitchFamily="34" charset="0"/>
-                <a:ea typeface="Be Vietnam Pro" pitchFamily="34" charset="-122"/>
-                <a:cs typeface="Be Vietnam Pro" pitchFamily="34" charset="-120"/>
-              </a:rPr>
-              <a:t> luồng theo</a:t>
-            </a:r>
-            <a:r>
-              <a:rPr lang="en-US" sz="2400" b="1" dirty="0" spc="-9" kern="0">
-                <a:solidFill>
-                  <a:srgbClr val="1F3FD1"/>
-                </a:solidFill>
-                <a:latin typeface="Be Vietnam Pro" pitchFamily="34" charset="0"/>
-                <a:ea typeface="Be Vietnam Pro" pitchFamily="34" charset="-122"/>
-                <a:cs typeface="Be Vietnam Pro" pitchFamily="34" charset="-120"/>
-              </a:rPr>
-              <a:t> nền</a:t>
-            </a:r>
-            <a:r>
-              <a:rPr lang="en-US" sz="2400" b="1" dirty="0" spc="-6" kern="0">
-                <a:solidFill>
-                  <a:srgbClr val="1F3FD1"/>
-                </a:solidFill>
-                <a:latin typeface="Be Vietnam Pro" pitchFamily="34" charset="0"/>
-                <a:ea typeface="Be Vietnam Pro" pitchFamily="34" charset="-122"/>
-                <a:cs typeface="Be Vietnam Pro" pitchFamily="34" charset="-120"/>
-              </a:rPr>
-              <a:t> tảng</a:t>
-            </a:r>
-            <a:endParaRPr lang="en-US" sz="2400" dirty="0"/>
-          </a:p>
-        </p:txBody>
-      </p:sp>
-      <p:sp>
-        <p:nvSpPr>
-          <p:cNvPr id="15" name="Text 13"/>
-          <p:cNvSpPr/>
-          <p:nvPr/>
-        </p:nvSpPr>
-        <p:spPr>
-          <a:xfrm>
-            <a:off x="7048500" y="4572000"/>
-            <a:ext cx="10096500" cy="876300"/>
-          </a:xfrm>
-          <a:prstGeom prst="rect">
-            <a:avLst/>
-          </a:prstGeom>
-          <a:noFill/>
-          <a:ln/>
-        </p:spPr>
-        <p:txBody>
-          <a:bodyPr wrap="square" lIns="0" tIns="0" rIns="0" bIns="0" rtlCol="0" anchor="ctr"/>
-          <a:lstStyle/>
-          <a:p>
-            <a:pPr algn="l" indent="0" marL="0">
-              <a:buNone/>
-            </a:pPr>
-            <a:r>
-              <a:rPr lang="en-US" sz="2400" dirty="0" spc="-30" kern="0">
-                <a:solidFill>
-                  <a:srgbClr val="14161C"/>
-                </a:solidFill>
-                <a:latin typeface="Be Vietnam Pro" pitchFamily="34" charset="0"/>
-                <a:ea typeface="Be Vietnam Pro" pitchFamily="34" charset="-122"/>
-                <a:cs typeface="Be Vietnam Pro" pitchFamily="34" charset="-120"/>
-              </a:rPr>
-              <a:t>Luật</a:t>
-            </a:r>
-            <a:r>
-              <a:rPr lang="en-US" sz="2400" dirty="0" spc="-1" kern="0">
-                <a:solidFill>
-                  <a:srgbClr val="14161C"/>
-                </a:solidFill>
-                <a:latin typeface="Be Vietnam Pro" pitchFamily="34" charset="0"/>
-                <a:ea typeface="Be Vietnam Pro" pitchFamily="34" charset="-122"/>
-                <a:cs typeface="Be Vietnam Pro" pitchFamily="34" charset="-120"/>
-              </a:rPr>
-              <a:t> theo</a:t>
-            </a:r>
-            <a:r>
-              <a:rPr lang="en-US" sz="2400" dirty="0" spc="0" kern="0">
-                <a:solidFill>
-                  <a:srgbClr val="14161C"/>
-                </a:solidFill>
-                <a:latin typeface="Be Vietnam Pro" pitchFamily="34" charset="0"/>
-                <a:ea typeface="Be Vietnam Pro" pitchFamily="34" charset="-122"/>
-                <a:cs typeface="Be Vietnam Pro" pitchFamily="34" charset="-120"/>
-              </a:rPr>
-              <a:t> header chọn</a:t>
-            </a:r>
-            <a:r>
-              <a:rPr lang="en-US" sz="2400" dirty="0" spc="2" kern="0">
-                <a:solidFill>
-                  <a:srgbClr val="14161C"/>
-                </a:solidFill>
-                <a:latin typeface="Be Vietnam Pro" pitchFamily="34" charset="0"/>
-                <a:ea typeface="Be Vietnam Pro" pitchFamily="34" charset="-122"/>
-                <a:cs typeface="Be Vietnam Pro" pitchFamily="34" charset="-120"/>
-              </a:rPr>
-              <a:t> nhóm</a:t>
-            </a:r>
-            <a:r>
-              <a:rPr lang="en-US" sz="2400" dirty="0" spc="-7" kern="0">
-                <a:solidFill>
-                  <a:srgbClr val="14161C"/>
-                </a:solidFill>
-                <a:latin typeface="Be Vietnam Pro" pitchFamily="34" charset="0"/>
-                <a:ea typeface="Be Vietnam Pro" pitchFamily="34" charset="-122"/>
-                <a:cs typeface="Be Vietnam Pro" pitchFamily="34" charset="-120"/>
-              </a:rPr>
-              <a:t> máy</a:t>
-            </a:r>
-            <a:r>
-              <a:rPr lang="en-US" sz="2400" dirty="0" spc="1" kern="0">
-                <a:solidFill>
-                  <a:srgbClr val="14161C"/>
-                </a:solidFill>
-                <a:latin typeface="Be Vietnam Pro" pitchFamily="34" charset="0"/>
-                <a:ea typeface="Be Vietnam Pro" pitchFamily="34" charset="-122"/>
-                <a:cs typeface="Be Vietnam Pro" pitchFamily="34" charset="-120"/>
-              </a:rPr>
-              <a:t> mobile</a:t>
-            </a:r>
-            <a:r>
-              <a:rPr lang="en-US" sz="2400" dirty="0" spc="-1" kern="0">
-                <a:solidFill>
-                  <a:srgbClr val="14161C"/>
-                </a:solidFill>
-                <a:latin typeface="Be Vietnam Pro" pitchFamily="34" charset="0"/>
-                <a:ea typeface="Be Vietnam Pro" pitchFamily="34" charset="-122"/>
-                <a:cs typeface="Be Vietnam Pro" pitchFamily="34" charset="-120"/>
-              </a:rPr>
-              <a:t> hoặc</a:t>
-            </a:r>
-            <a:r>
-              <a:rPr lang="en-US" sz="2400" dirty="0" spc="-5" kern="0">
-                <a:solidFill>
-                  <a:srgbClr val="14161C"/>
-                </a:solidFill>
-                <a:latin typeface="Be Vietnam Pro" pitchFamily="34" charset="0"/>
-                <a:ea typeface="Be Vietnam Pro" pitchFamily="34" charset="-122"/>
-                <a:cs typeface="Be Vietnam Pro" pitchFamily="34" charset="-120"/>
-              </a:rPr>
-              <a:t> desktop.</a:t>
-            </a:r>
-            <a:endParaRPr lang="en-US" sz="2400" dirty="0"/>
-          </a:p>
-        </p:txBody>
-      </p:sp>
-      <p:sp>
-        <p:nvSpPr>
-          <p:cNvPr id="16" name="Shape 14"/>
-          <p:cNvSpPr/>
-          <p:nvPr/>
-        </p:nvSpPr>
-        <p:spPr>
-          <a:xfrm>
-            <a:off x="914400" y="5562600"/>
-            <a:ext cx="16459200" cy="876300"/>
-          </a:xfrm>
-          <a:prstGeom prst="roundRect">
-            <a:avLst>
-              <a:gd name="adj" fmla="val 50000"/>
-            </a:avLst>
-          </a:prstGeom>
-          <a:solidFill>
-            <a:srgbClr val="F3DFB8"/>
-          </a:solidFill>
-          <a:ln/>
-        </p:spPr>
-      </p:sp>
-      <p:sp>
-        <p:nvSpPr>
-          <p:cNvPr id="17" name="Text 15"/>
-          <p:cNvSpPr/>
-          <p:nvPr/>
-        </p:nvSpPr>
-        <p:spPr>
-          <a:xfrm>
-            <a:off x="1047750" y="5695950"/>
-            <a:ext cx="609600" cy="609600"/>
-          </a:xfrm>
-          <a:prstGeom prst="roundRect">
-            <a:avLst>
-              <a:gd name="adj" fmla="val 50000"/>
-            </a:avLst>
-          </a:prstGeom>
-          <a:solidFill>
-            <a:srgbClr val="B45309"/>
-          </a:solidFill>
-          <a:ln/>
-        </p:spPr>
-        <p:txBody>
-          <a:bodyPr wrap="square" lIns="0" tIns="0" rIns="0" bIns="0" rtlCol="0" anchor="ctr"/>
-          <a:lstStyle/>
-          <a:p>
-            <a:pPr algn="ctr" indent="0" marL="0">
-              <a:buNone/>
-            </a:pPr>
-            <a:r>
-              <a:rPr lang="en-US" sz="3000" dirty="0" spc="-4" kern="0">
-                <a:solidFill>
-                  <a:srgbClr val="FFFFFF"/>
-                </a:solidFill>
-                <a:latin typeface="Bricolage Grotesque ExtraBold" pitchFamily="34" charset="0"/>
-                <a:ea typeface="Bricolage Grotesque ExtraBold" pitchFamily="34" charset="-122"/>
-                <a:cs typeface="Bricolage Grotesque ExtraBold" pitchFamily="34" charset="-120"/>
-              </a:rPr>
-              <a:t>4</a:t>
-            </a:r>
-            <a:endParaRPr lang="en-US" sz="3000" dirty="0"/>
-          </a:p>
-        </p:txBody>
-      </p:sp>
-      <p:sp>
-        <p:nvSpPr>
-          <p:cNvPr id="18" name="Text 16"/>
-          <p:cNvSpPr/>
-          <p:nvPr/>
-        </p:nvSpPr>
-        <p:spPr>
-          <a:xfrm>
-            <a:off x="1943100" y="5562600"/>
-            <a:ext cx="4953000" cy="876300"/>
-          </a:xfrm>
-          <a:prstGeom prst="rect">
-            <a:avLst/>
-          </a:prstGeom>
-          <a:noFill/>
-          <a:ln/>
-        </p:spPr>
-        <p:txBody>
-          <a:bodyPr wrap="square" lIns="0" tIns="0" rIns="0" bIns="0" rtlCol="0" anchor="ctr"/>
-          <a:lstStyle/>
-          <a:p>
-            <a:pPr algn="l" indent="0" marL="0">
-              <a:buNone/>
-            </a:pPr>
-            <a:r>
-              <a:rPr lang="en-US" sz="2400" b="1" dirty="0" spc="-42" kern="0">
-                <a:solidFill>
-                  <a:srgbClr val="B45309"/>
-                </a:solidFill>
-                <a:latin typeface="Be Vietnam Pro" pitchFamily="34" charset="0"/>
-                <a:ea typeface="Be Vietnam Pro" pitchFamily="34" charset="-122"/>
-                <a:cs typeface="Be Vietnam Pro" pitchFamily="34" charset="-120"/>
-              </a:rPr>
-              <a:t>Kết</a:t>
-            </a:r>
-            <a:r>
-              <a:rPr lang="en-US" sz="2400" b="1" dirty="0" spc="0" kern="0">
-                <a:solidFill>
-                  <a:srgbClr val="B45309"/>
-                </a:solidFill>
-                <a:latin typeface="Be Vietnam Pro" pitchFamily="34" charset="0"/>
-                <a:ea typeface="Be Vietnam Pro" pitchFamily="34" charset="-122"/>
-                <a:cs typeface="Be Vietnam Pro" pitchFamily="34" charset="-120"/>
-              </a:rPr>
-              <a:t> thúc</a:t>
-            </a:r>
-            <a:r>
-              <a:rPr lang="en-US" sz="2400" b="1" dirty="0" spc="1" kern="0">
-                <a:solidFill>
-                  <a:srgbClr val="B45309"/>
-                </a:solidFill>
-                <a:latin typeface="Be Vietnam Pro" pitchFamily="34" charset="0"/>
-                <a:ea typeface="Be Vietnam Pro" pitchFamily="34" charset="-122"/>
-                <a:cs typeface="Be Vietnam Pro" pitchFamily="34" charset="-120"/>
-              </a:rPr>
-              <a:t> TLS</a:t>
-            </a:r>
-            <a:endParaRPr lang="en-US" sz="2400" dirty="0"/>
-          </a:p>
-        </p:txBody>
-      </p:sp>
-      <p:sp>
-        <p:nvSpPr>
-          <p:cNvPr id="19" name="Text 17"/>
-          <p:cNvSpPr/>
-          <p:nvPr/>
-        </p:nvSpPr>
-        <p:spPr>
-          <a:xfrm>
-            <a:off x="7048500" y="5562600"/>
-            <a:ext cx="10096500" cy="876300"/>
-          </a:xfrm>
-          <a:prstGeom prst="rect">
-            <a:avLst/>
-          </a:prstGeom>
-          <a:noFill/>
-          <a:ln/>
-        </p:spPr>
-        <p:txBody>
-          <a:bodyPr wrap="square" lIns="0" tIns="0" rIns="0" bIns="0" rtlCol="0" anchor="ctr"/>
-          <a:lstStyle/>
-          <a:p>
-            <a:pPr algn="l" indent="0" marL="0">
-              <a:buNone/>
-            </a:pPr>
-            <a:r>
-              <a:rPr lang="en-US" sz="2400" dirty="0" spc="-46" kern="0">
-                <a:solidFill>
-                  <a:srgbClr val="14161C"/>
-                </a:solidFill>
-                <a:latin typeface="Be Vietnam Pro" pitchFamily="34" charset="0"/>
-                <a:ea typeface="Be Vietnam Pro" pitchFamily="34" charset="-122"/>
-                <a:cs typeface="Be Vietnam Pro" pitchFamily="34" charset="-120"/>
-              </a:rPr>
-              <a:t>Kết</a:t>
-            </a:r>
-            <a:r>
-              <a:rPr lang="en-US" sz="2400" dirty="0" spc="0" kern="0">
-                <a:solidFill>
-                  <a:srgbClr val="14161C"/>
-                </a:solidFill>
-                <a:latin typeface="Be Vietnam Pro" pitchFamily="34" charset="0"/>
-                <a:ea typeface="Be Vietnam Pro" pitchFamily="34" charset="-122"/>
-                <a:cs typeface="Be Vietnam Pro" pitchFamily="34" charset="-120"/>
-              </a:rPr>
-              <a:t> nối</a:t>
-            </a:r>
-            <a:r>
-              <a:rPr lang="en-US" sz="2400" dirty="0" spc="-1" kern="0">
-                <a:solidFill>
-                  <a:srgbClr val="14161C"/>
-                </a:solidFill>
-                <a:latin typeface="Be Vietnam Pro" pitchFamily="34" charset="0"/>
-                <a:ea typeface="Be Vietnam Pro" pitchFamily="34" charset="-122"/>
-                <a:cs typeface="Be Vietnam Pro" pitchFamily="34" charset="-120"/>
-              </a:rPr>
-              <a:t> HTTPS</a:t>
-            </a:r>
-            <a:r>
-              <a:rPr lang="en-US" sz="2400" dirty="0" spc="3" kern="0">
-                <a:solidFill>
-                  <a:srgbClr val="14161C"/>
-                </a:solidFill>
-                <a:latin typeface="Be Vietnam Pro" pitchFamily="34" charset="0"/>
-                <a:ea typeface="Be Vietnam Pro" pitchFamily="34" charset="-122"/>
-                <a:cs typeface="Be Vietnam Pro" pitchFamily="34" charset="-120"/>
-              </a:rPr>
-              <a:t> từ</a:t>
-            </a:r>
-            <a:r>
-              <a:rPr lang="en-US" sz="2400" dirty="0" spc="6" kern="0">
-                <a:solidFill>
-                  <a:srgbClr val="14161C"/>
-                </a:solidFill>
-                <a:latin typeface="Be Vietnam Pro" pitchFamily="34" charset="0"/>
-                <a:ea typeface="Be Vietnam Pro" pitchFamily="34" charset="-122"/>
-                <a:cs typeface="Be Vietnam Pro" pitchFamily="34" charset="-120"/>
-              </a:rPr>
-              <a:t> người</a:t>
-            </a:r>
-            <a:r>
-              <a:rPr lang="en-US" sz="2400" dirty="0" spc="4" kern="0">
-                <a:solidFill>
-                  <a:srgbClr val="14161C"/>
-                </a:solidFill>
-                <a:latin typeface="Be Vietnam Pro" pitchFamily="34" charset="0"/>
-                <a:ea typeface="Be Vietnam Pro" pitchFamily="34" charset="-122"/>
-                <a:cs typeface="Be Vietnam Pro" pitchFamily="34" charset="-120"/>
-              </a:rPr>
-              <a:t> dùng</a:t>
-            </a:r>
-            <a:r>
-              <a:rPr lang="en-US" sz="2400" dirty="0" spc="-34" kern="0">
-                <a:solidFill>
-                  <a:srgbClr val="14161C"/>
-                </a:solidFill>
-                <a:latin typeface="Be Vietnam Pro" pitchFamily="34" charset="0"/>
-                <a:ea typeface="Be Vietnam Pro" pitchFamily="34" charset="-122"/>
-                <a:cs typeface="Be Vietnam Pro" pitchFamily="34" charset="-120"/>
-              </a:rPr>
-              <a:t> kết</a:t>
-            </a:r>
-            <a:r>
-              <a:rPr lang="en-US" sz="2400" dirty="0" spc="1" kern="0">
-                <a:solidFill>
-                  <a:srgbClr val="14161C"/>
-                </a:solidFill>
-                <a:latin typeface="Be Vietnam Pro" pitchFamily="34" charset="0"/>
-                <a:ea typeface="Be Vietnam Pro" pitchFamily="34" charset="-122"/>
-                <a:cs typeface="Be Vietnam Pro" pitchFamily="34" charset="-120"/>
-              </a:rPr>
-              <a:t> thúc</a:t>
-            </a:r>
-            <a:r>
-              <a:rPr lang="en-US" sz="2400" dirty="0" spc="-11" kern="0">
-                <a:solidFill>
-                  <a:srgbClr val="14161C"/>
-                </a:solidFill>
-                <a:latin typeface="Be Vietnam Pro" pitchFamily="34" charset="0"/>
-                <a:ea typeface="Be Vietnam Pro" pitchFamily="34" charset="-122"/>
-                <a:cs typeface="Be Vietnam Pro" pitchFamily="34" charset="-120"/>
-              </a:rPr>
-              <a:t> tại</a:t>
-            </a:r>
-            <a:r>
-              <a:rPr lang="en-US" sz="2400" dirty="0" spc="1" kern="0">
-                <a:solidFill>
-                  <a:srgbClr val="14161C"/>
-                </a:solidFill>
-                <a:latin typeface="Be Vietnam Pro" pitchFamily="34" charset="0"/>
-                <a:ea typeface="Be Vietnam Pro" pitchFamily="34" charset="-122"/>
-                <a:cs typeface="Be Vietnam Pro" pitchFamily="34" charset="-120"/>
-              </a:rPr>
-              <a:t> LB.</a:t>
-            </a:r>
-            <a:endParaRPr lang="en-US" sz="2400" dirty="0"/>
-          </a:p>
-        </p:txBody>
-      </p:sp>
-      <p:sp>
-        <p:nvSpPr>
-          <p:cNvPr id="20" name="Shape 18"/>
-          <p:cNvSpPr/>
-          <p:nvPr/>
-        </p:nvSpPr>
-        <p:spPr>
-          <a:xfrm>
-            <a:off x="914400" y="6553200"/>
-            <a:ext cx="16459200" cy="876300"/>
-          </a:xfrm>
-          <a:prstGeom prst="roundRect">
-            <a:avLst>
-              <a:gd name="adj" fmla="val 50000"/>
-            </a:avLst>
-          </a:prstGeom>
-          <a:solidFill>
-            <a:srgbClr val="CFE8E2"/>
-          </a:solidFill>
-          <a:ln/>
-        </p:spPr>
-      </p:sp>
-      <p:sp>
-        <p:nvSpPr>
-          <p:cNvPr id="21" name="Text 19"/>
-          <p:cNvSpPr/>
-          <p:nvPr/>
-        </p:nvSpPr>
-        <p:spPr>
-          <a:xfrm>
-            <a:off x="1047750" y="6686550"/>
-            <a:ext cx="609600" cy="609600"/>
-          </a:xfrm>
-          <a:prstGeom prst="roundRect">
-            <a:avLst>
-              <a:gd name="adj" fmla="val 50000"/>
-            </a:avLst>
-          </a:prstGeom>
-          <a:solidFill>
-            <a:srgbClr val="0F766E"/>
-          </a:solidFill>
-          <a:ln/>
-        </p:spPr>
-        <p:txBody>
-          <a:bodyPr wrap="square" lIns="0" tIns="0" rIns="0" bIns="0" rtlCol="0" anchor="ctr"/>
-          <a:lstStyle/>
-          <a:p>
-            <a:pPr algn="ctr" indent="0" marL="0">
-              <a:buNone/>
-            </a:pPr>
-            <a:r>
-              <a:rPr lang="en-US" sz="3000" dirty="0" spc="-5" kern="0">
-                <a:solidFill>
-                  <a:srgbClr val="FFFFFF"/>
-                </a:solidFill>
-                <a:latin typeface="Bricolage Grotesque ExtraBold" pitchFamily="34" charset="0"/>
-                <a:ea typeface="Bricolage Grotesque ExtraBold" pitchFamily="34" charset="-122"/>
-                <a:cs typeface="Bricolage Grotesque ExtraBold" pitchFamily="34" charset="-120"/>
-              </a:rPr>
-              <a:t>5</a:t>
-            </a:r>
-            <a:endParaRPr lang="en-US" sz="3000" dirty="0"/>
-          </a:p>
-        </p:txBody>
-      </p:sp>
-      <p:sp>
-        <p:nvSpPr>
-          <p:cNvPr id="22" name="Text 20"/>
-          <p:cNvSpPr/>
-          <p:nvPr/>
-        </p:nvSpPr>
-        <p:spPr>
-          <a:xfrm>
-            <a:off x="1943100" y="6553200"/>
-            <a:ext cx="4953000" cy="876300"/>
-          </a:xfrm>
-          <a:prstGeom prst="rect">
-            <a:avLst/>
-          </a:prstGeom>
-          <a:noFill/>
-          <a:ln/>
-        </p:spPr>
-        <p:txBody>
-          <a:bodyPr wrap="square" lIns="0" tIns="0" rIns="0" bIns="0" rtlCol="0" anchor="ctr"/>
-          <a:lstStyle/>
-          <a:p>
-            <a:pPr algn="l" indent="0" marL="0">
-              <a:buNone/>
-            </a:pPr>
-            <a:r>
-              <a:rPr lang="en-US" sz="2400" b="1" dirty="0" spc="-1" kern="0">
-                <a:solidFill>
-                  <a:srgbClr val="0F766E"/>
-                </a:solidFill>
-                <a:latin typeface="Be Vietnam Pro" pitchFamily="34" charset="0"/>
-                <a:ea typeface="Be Vietnam Pro" pitchFamily="34" charset="-122"/>
-                <a:cs typeface="Be Vietnam Pro" pitchFamily="34" charset="-120"/>
-              </a:rPr>
-              <a:t>Chia</a:t>
-            </a:r>
-            <a:r>
-              <a:rPr lang="en-US" sz="2400" b="1" dirty="0" spc="-2" kern="0">
-                <a:solidFill>
-                  <a:srgbClr val="0F766E"/>
-                </a:solidFill>
-                <a:latin typeface="Be Vietnam Pro" pitchFamily="34" charset="0"/>
-                <a:ea typeface="Be Vietnam Pro" pitchFamily="34" charset="-122"/>
-                <a:cs typeface="Be Vietnam Pro" pitchFamily="34" charset="-120"/>
-              </a:rPr>
-              <a:t> tải</a:t>
-            </a:r>
-            <a:r>
-              <a:rPr lang="en-US" sz="2400" b="1" dirty="0" spc="-17" kern="0">
-                <a:solidFill>
-                  <a:srgbClr val="0F766E"/>
-                </a:solidFill>
-                <a:latin typeface="Be Vietnam Pro" pitchFamily="34" charset="0"/>
-                <a:ea typeface="Be Vietnam Pro" pitchFamily="34" charset="-122"/>
-                <a:cs typeface="Be Vietnam Pro" pitchFamily="34" charset="-120"/>
-              </a:rPr>
-              <a:t> xuyên</a:t>
-            </a:r>
-            <a:r>
-              <a:rPr lang="en-US" sz="2400" b="1" dirty="0" spc="-4" kern="0">
-                <a:solidFill>
-                  <a:srgbClr val="0F766E"/>
-                </a:solidFill>
-                <a:latin typeface="Be Vietnam Pro" pitchFamily="34" charset="0"/>
-                <a:ea typeface="Be Vietnam Pro" pitchFamily="34" charset="-122"/>
-                <a:cs typeface="Be Vietnam Pro" pitchFamily="34" charset="-120"/>
-              </a:rPr>
-              <a:t> vùng</a:t>
-            </a:r>
-            <a:endParaRPr lang="en-US" sz="2400" dirty="0"/>
-          </a:p>
-        </p:txBody>
-      </p:sp>
-      <p:sp>
-        <p:nvSpPr>
-          <p:cNvPr id="23" name="Text 21"/>
-          <p:cNvSpPr/>
-          <p:nvPr/>
-        </p:nvSpPr>
-        <p:spPr>
-          <a:xfrm>
-            <a:off x="7048500" y="6553200"/>
-            <a:ext cx="10096500" cy="876300"/>
-          </a:xfrm>
-          <a:prstGeom prst="rect">
-            <a:avLst/>
-          </a:prstGeom>
-          <a:noFill/>
-          <a:ln/>
-        </p:spPr>
-        <p:txBody>
-          <a:bodyPr wrap="square" lIns="0" tIns="0" rIns="0" bIns="0" rtlCol="0" anchor="ctr"/>
-          <a:lstStyle/>
-          <a:p>
-            <a:pPr algn="l" indent="0" marL="0">
-              <a:buNone/>
-            </a:pPr>
-            <a:r>
-              <a:rPr lang="en-US" sz="2400" dirty="0" spc="-23" kern="0">
-                <a:solidFill>
-                  <a:srgbClr val="14161C"/>
-                </a:solidFill>
-                <a:latin typeface="Be Vietnam Pro" pitchFamily="34" charset="0"/>
-                <a:ea typeface="Be Vietnam Pro" pitchFamily="34" charset="-122"/>
-                <a:cs typeface="Be Vietnam Pro" pitchFamily="34" charset="-120"/>
-              </a:rPr>
-              <a:t>Request</a:t>
-            </a:r>
-            <a:r>
-              <a:rPr lang="en-US" sz="2400" dirty="0" spc="-11" kern="0">
-                <a:solidFill>
-                  <a:srgbClr val="14161C"/>
-                </a:solidFill>
-                <a:latin typeface="Be Vietnam Pro" pitchFamily="34" charset="0"/>
-                <a:ea typeface="Be Vietnam Pro" pitchFamily="34" charset="-122"/>
-                <a:cs typeface="Be Vietnam Pro" pitchFamily="34" charset="-120"/>
-              </a:rPr>
-              <a:t> tới</a:t>
-            </a:r>
-            <a:r>
-              <a:rPr lang="en-US" sz="2400" dirty="0" spc="-6" kern="0">
-                <a:solidFill>
-                  <a:srgbClr val="14161C"/>
-                </a:solidFill>
-                <a:latin typeface="Be Vietnam Pro" pitchFamily="34" charset="0"/>
-                <a:ea typeface="Be Vietnam Pro" pitchFamily="34" charset="-122"/>
-                <a:cs typeface="Be Vietnam Pro" pitchFamily="34" charset="-120"/>
-              </a:rPr>
-              <a:t> máy</a:t>
-            </a:r>
-            <a:r>
-              <a:rPr lang="en-US" sz="2400" dirty="0" spc="3" kern="0">
-                <a:solidFill>
-                  <a:srgbClr val="14161C"/>
-                </a:solidFill>
-                <a:latin typeface="Be Vietnam Pro" pitchFamily="34" charset="0"/>
-                <a:ea typeface="Be Vietnam Pro" pitchFamily="34" charset="-122"/>
-                <a:cs typeface="Be Vietnam Pro" pitchFamily="34" charset="-120"/>
-              </a:rPr>
-              <a:t> ở</a:t>
-            </a:r>
-            <a:r>
-              <a:rPr lang="en-US" sz="2400" dirty="0" spc="-1" kern="0">
-                <a:solidFill>
-                  <a:srgbClr val="14161C"/>
-                </a:solidFill>
-                <a:latin typeface="Be Vietnam Pro" pitchFamily="34" charset="0"/>
-                <a:ea typeface="Be Vietnam Pro" pitchFamily="34" charset="-122"/>
-                <a:cs typeface="Be Vietnam Pro" pitchFamily="34" charset="-120"/>
-              </a:rPr>
-              <a:t> nhiều</a:t>
-            </a:r>
-            <a:r>
-              <a:rPr lang="en-US" sz="2400" dirty="0" spc="1" kern="0">
-                <a:solidFill>
-                  <a:srgbClr val="14161C"/>
-                </a:solidFill>
-                <a:latin typeface="Be Vietnam Pro" pitchFamily="34" charset="0"/>
-                <a:ea typeface="Be Vietnam Pro" pitchFamily="34" charset="-122"/>
-                <a:cs typeface="Be Vietnam Pro" pitchFamily="34" charset="-120"/>
-              </a:rPr>
-              <a:t> vùng</a:t>
-            </a:r>
-            <a:r>
-              <a:rPr lang="en-US" sz="2400" dirty="0" spc="-5" kern="0">
-                <a:solidFill>
-                  <a:srgbClr val="14161C"/>
-                </a:solidFill>
-                <a:latin typeface="Be Vietnam Pro" pitchFamily="34" charset="0"/>
-                <a:ea typeface="Be Vietnam Pro" pitchFamily="34" charset="-122"/>
-                <a:cs typeface="Be Vietnam Pro" pitchFamily="34" charset="-120"/>
-              </a:rPr>
-              <a:t> sẵn</a:t>
-            </a:r>
-            <a:r>
-              <a:rPr lang="en-US" sz="2400" dirty="0" spc="-4" kern="0">
-                <a:solidFill>
-                  <a:srgbClr val="14161C"/>
-                </a:solidFill>
-                <a:latin typeface="Be Vietnam Pro" pitchFamily="34" charset="0"/>
-                <a:ea typeface="Be Vietnam Pro" pitchFamily="34" charset="-122"/>
-                <a:cs typeface="Be Vietnam Pro" pitchFamily="34" charset="-120"/>
-              </a:rPr>
-              <a:t> sàng</a:t>
-            </a:r>
-            <a:r>
-              <a:rPr lang="en-US" sz="2400" dirty="0" spc="19" kern="0">
-                <a:solidFill>
-                  <a:srgbClr val="14161C"/>
-                </a:solidFill>
-                <a:latin typeface="Be Vietnam Pro" pitchFamily="34" charset="0"/>
-                <a:ea typeface="Be Vietnam Pro" pitchFamily="34" charset="-122"/>
-                <a:cs typeface="Be Vietnam Pro" pitchFamily="34" charset="-120"/>
-              </a:rPr>
-              <a:t> đã</a:t>
-            </a:r>
-            <a:r>
-              <a:rPr lang="en-US" sz="2400" dirty="0" spc="-10" kern="0">
-                <a:solidFill>
-                  <a:srgbClr val="14161C"/>
-                </a:solidFill>
-                <a:latin typeface="Be Vietnam Pro" pitchFamily="34" charset="0"/>
-                <a:ea typeface="Be Vietnam Pro" pitchFamily="34" charset="-122"/>
-                <a:cs typeface="Be Vietnam Pro" pitchFamily="34" charset="-120"/>
-              </a:rPr>
-              <a:t> bật.</a:t>
-            </a:r>
-            <a:endParaRPr lang="en-US" sz="2400" dirty="0"/>
-          </a:p>
-        </p:txBody>
-      </p:sp>
-      <p:sp>
-        <p:nvSpPr>
-          <p:cNvPr id="24" name="Shape 22"/>
-          <p:cNvSpPr/>
-          <p:nvPr/>
-        </p:nvSpPr>
-        <p:spPr>
-          <a:xfrm>
-            <a:off x="914400" y="7543800"/>
-            <a:ext cx="16459200" cy="876300"/>
-          </a:xfrm>
-          <a:prstGeom prst="roundRect">
-            <a:avLst>
-              <a:gd name="adj" fmla="val 50000"/>
-            </a:avLst>
-          </a:prstGeom>
-          <a:solidFill>
-            <a:srgbClr val="F8D9D0"/>
-          </a:solidFill>
-          <a:ln/>
-        </p:spPr>
-      </p:sp>
-      <p:sp>
-        <p:nvSpPr>
-          <p:cNvPr id="25" name="Text 23"/>
-          <p:cNvSpPr/>
-          <p:nvPr/>
-        </p:nvSpPr>
-        <p:spPr>
-          <a:xfrm>
-            <a:off x="1047750" y="7677150"/>
-            <a:ext cx="609600" cy="609600"/>
-          </a:xfrm>
-          <a:prstGeom prst="roundRect">
-            <a:avLst>
-              <a:gd name="adj" fmla="val 50000"/>
-            </a:avLst>
-          </a:prstGeom>
-          <a:solidFill>
-            <a:srgbClr val="E8472B"/>
-          </a:solidFill>
-          <a:ln/>
-        </p:spPr>
-        <p:txBody>
-          <a:bodyPr wrap="square" lIns="0" tIns="0" rIns="0" bIns="0" rtlCol="0" anchor="ctr"/>
-          <a:lstStyle/>
-          <a:p>
-            <a:pPr algn="ctr" indent="0" marL="0">
-              <a:buNone/>
-            </a:pPr>
-            <a:r>
-              <a:rPr lang="en-US" sz="3000" dirty="0" spc="1" kern="0">
-                <a:solidFill>
-                  <a:srgbClr val="FFFFFF"/>
-                </a:solidFill>
-                <a:latin typeface="Bricolage Grotesque ExtraBold" pitchFamily="34" charset="0"/>
-                <a:ea typeface="Bricolage Grotesque ExtraBold" pitchFamily="34" charset="-122"/>
-                <a:cs typeface="Bricolage Grotesque ExtraBold" pitchFamily="34" charset="-120"/>
-              </a:rPr>
-              <a:t>6</a:t>
-            </a:r>
-            <a:endParaRPr lang="en-US" sz="3000" dirty="0"/>
-          </a:p>
-        </p:txBody>
-      </p:sp>
-      <p:sp>
-        <p:nvSpPr>
-          <p:cNvPr id="26" name="Text 24"/>
-          <p:cNvSpPr/>
-          <p:nvPr/>
-        </p:nvSpPr>
-        <p:spPr>
-          <a:xfrm>
-            <a:off x="1943100" y="7543800"/>
-            <a:ext cx="4953000" cy="876300"/>
-          </a:xfrm>
-          <a:prstGeom prst="rect">
-            <a:avLst/>
-          </a:prstGeom>
-          <a:noFill/>
-          <a:ln/>
-        </p:spPr>
-        <p:txBody>
-          <a:bodyPr wrap="square" lIns="0" tIns="0" rIns="0" bIns="0" rtlCol="0" anchor="ctr"/>
-          <a:lstStyle/>
-          <a:p>
-            <a:pPr algn="l" indent="0" marL="0">
-              <a:buNone/>
-            </a:pPr>
-            <a:r>
-              <a:rPr lang="en-US" sz="2400" b="1" dirty="0" spc="0" kern="0">
-                <a:solidFill>
-                  <a:srgbClr val="E8472B"/>
-                </a:solidFill>
-                <a:latin typeface="Be Vietnam Pro" pitchFamily="34" charset="0"/>
-                <a:ea typeface="Be Vietnam Pro" pitchFamily="34" charset="-122"/>
-                <a:cs typeface="Be Vietnam Pro" pitchFamily="34" charset="-120"/>
-              </a:rPr>
-              <a:t>Giữ</a:t>
-            </a:r>
-            <a:r>
-              <a:rPr lang="en-US" sz="2400" b="1" dirty="0" spc="-6" kern="0">
-                <a:solidFill>
-                  <a:srgbClr val="E8472B"/>
-                </a:solidFill>
-                <a:latin typeface="Be Vietnam Pro" pitchFamily="34" charset="0"/>
-                <a:ea typeface="Be Vietnam Pro" pitchFamily="34" charset="-122"/>
-                <a:cs typeface="Be Vietnam Pro" pitchFamily="34" charset="-120"/>
-              </a:rPr>
-              <a:t> phiên</a:t>
-            </a:r>
-            <a:endParaRPr lang="en-US" sz="2400" dirty="0"/>
-          </a:p>
-        </p:txBody>
-      </p:sp>
-      <p:sp>
-        <p:nvSpPr>
-          <p:cNvPr id="27" name="Text 25"/>
-          <p:cNvSpPr/>
-          <p:nvPr/>
-        </p:nvSpPr>
-        <p:spPr>
-          <a:xfrm>
-            <a:off x="7048500" y="7543800"/>
-            <a:ext cx="10096500" cy="876300"/>
-          </a:xfrm>
-          <a:prstGeom prst="rect">
-            <a:avLst/>
-          </a:prstGeom>
-          <a:noFill/>
-          <a:ln/>
-        </p:spPr>
-        <p:txBody>
-          <a:bodyPr wrap="square" lIns="0" tIns="0" rIns="0" bIns="0" rtlCol="0" anchor="ctr"/>
-          <a:lstStyle/>
-          <a:p>
-            <a:pPr algn="l" indent="0" marL="0">
-              <a:buNone/>
-            </a:pPr>
-            <a:r>
-              <a:rPr lang="en-US" sz="2400" dirty="0" spc="-3" kern="0">
-                <a:solidFill>
-                  <a:srgbClr val="14161C"/>
-                </a:solidFill>
-                <a:latin typeface="Be Vietnam Pro" pitchFamily="34" charset="0"/>
-                <a:ea typeface="Be Vietnam Pro" pitchFamily="34" charset="-122"/>
-                <a:cs typeface="Be Vietnam Pro" pitchFamily="34" charset="-120"/>
-              </a:rPr>
-              <a:t>Nhiều</a:t>
-            </a:r>
-            <a:r>
-              <a:rPr lang="en-US" sz="2400" dirty="0" spc="7" kern="0">
-                <a:solidFill>
-                  <a:srgbClr val="14161C"/>
-                </a:solidFill>
-                <a:latin typeface="Be Vietnam Pro" pitchFamily="34" charset="0"/>
-                <a:ea typeface="Be Vietnam Pro" pitchFamily="34" charset="-122"/>
-                <a:cs typeface="Be Vietnam Pro" pitchFamily="34" charset="-120"/>
-              </a:rPr>
-              <a:t> lượt</a:t>
-            </a:r>
-            <a:r>
-              <a:rPr lang="en-US" sz="2400" dirty="0" spc="2" kern="0">
-                <a:solidFill>
-                  <a:srgbClr val="14161C"/>
-                </a:solidFill>
-                <a:latin typeface="Be Vietnam Pro" pitchFamily="34" charset="0"/>
-                <a:ea typeface="Be Vietnam Pro" pitchFamily="34" charset="-122"/>
-                <a:cs typeface="Be Vietnam Pro" pitchFamily="34" charset="-120"/>
-              </a:rPr>
-              <a:t> của cùng</a:t>
-            </a:r>
-            <a:r>
-              <a:rPr lang="en-US" sz="2400" dirty="0" spc="6" kern="0">
-                <a:solidFill>
-                  <a:srgbClr val="14161C"/>
-                </a:solidFill>
-                <a:latin typeface="Be Vietnam Pro" pitchFamily="34" charset="0"/>
-                <a:ea typeface="Be Vietnam Pro" pitchFamily="34" charset="-122"/>
-                <a:cs typeface="Be Vietnam Pro" pitchFamily="34" charset="-120"/>
-              </a:rPr>
-              <a:t> người</a:t>
-            </a:r>
-            <a:r>
-              <a:rPr lang="en-US" sz="2400" dirty="0" spc="4" kern="0">
-                <a:solidFill>
-                  <a:srgbClr val="14161C"/>
-                </a:solidFill>
-                <a:latin typeface="Be Vietnam Pro" pitchFamily="34" charset="0"/>
-                <a:ea typeface="Be Vietnam Pro" pitchFamily="34" charset="-122"/>
-                <a:cs typeface="Be Vietnam Pro" pitchFamily="34" charset="-120"/>
-              </a:rPr>
-              <a:t> dùng</a:t>
-            </a:r>
-            <a:r>
-              <a:rPr lang="en-US" sz="2400" dirty="0" spc="-18" kern="0">
-                <a:solidFill>
-                  <a:srgbClr val="14161C"/>
-                </a:solidFill>
-                <a:latin typeface="Be Vietnam Pro" pitchFamily="34" charset="0"/>
-                <a:ea typeface="Be Vietnam Pro" pitchFamily="34" charset="-122"/>
-                <a:cs typeface="Be Vietnam Pro" pitchFamily="34" charset="-120"/>
-              </a:rPr>
-              <a:t> về</a:t>
-            </a:r>
-            <a:r>
-              <a:rPr lang="en-US" sz="2400" dirty="0" spc="2" kern="0">
-                <a:solidFill>
-                  <a:srgbClr val="14161C"/>
-                </a:solidFill>
-                <a:latin typeface="Be Vietnam Pro" pitchFamily="34" charset="0"/>
-                <a:ea typeface="Be Vietnam Pro" pitchFamily="34" charset="-122"/>
-                <a:cs typeface="Be Vietnam Pro" pitchFamily="34" charset="-120"/>
-              </a:rPr>
-              <a:t> cùng</a:t>
-            </a:r>
-            <a:r>
-              <a:rPr lang="en-US" sz="2400" dirty="0" spc="-5" kern="0">
-                <a:solidFill>
-                  <a:srgbClr val="14161C"/>
-                </a:solidFill>
-                <a:latin typeface="Be Vietnam Pro" pitchFamily="34" charset="0"/>
-                <a:ea typeface="Be Vietnam Pro" pitchFamily="34" charset="-122"/>
-                <a:cs typeface="Be Vietnam Pro" pitchFamily="34" charset="-120"/>
-              </a:rPr>
-              <a:t> máy.</a:t>
-            </a:r>
-            <a:endParaRPr lang="en-US" sz="2400" dirty="0"/>
-          </a:p>
-        </p:txBody>
-      </p:sp>
-      <p:sp>
-        <p:nvSpPr>
-          <p:cNvPr id="28" name="Connector line-1792291005668-397919371"/>
+          <p:cNvPr id="2" name="Connector line-1792291005668-397919371"/>
           <p:cNvSpPr/>
           <p:nvPr/>
         </p:nvSpPr>
@@ -19500,7 +17846,7 @@
       </p:sp>
       <p:sp>
         <p:nvSpPr>
-          <p:cNvPr id="29" name="Shape 27"/>
+          <p:cNvPr id="3" name="Shape 1"/>
           <p:cNvSpPr/>
           <p:nvPr/>
         </p:nvSpPr>
@@ -19525,7 +17871,7 @@
       </p:sp>
       <p:sp>
         <p:nvSpPr>
-          <p:cNvPr id="30" name="Shape 28"/>
+          <p:cNvPr id="4" name="Shape 2"/>
           <p:cNvSpPr/>
           <p:nvPr/>
         </p:nvSpPr>
@@ -19550,7 +17896,7 @@
       </p:sp>
       <p:sp>
         <p:nvSpPr>
-          <p:cNvPr id="31" name="Shape 29"/>
+          <p:cNvPr id="5" name="Shape 3"/>
           <p:cNvSpPr/>
           <p:nvPr/>
         </p:nvSpPr>
@@ -19575,7 +17921,7 @@
       </p:sp>
       <p:sp>
         <p:nvSpPr>
-          <p:cNvPr id="32" name="Shape 30"/>
+          <p:cNvPr id="6" name="Shape 4"/>
           <p:cNvSpPr/>
           <p:nvPr/>
         </p:nvSpPr>
@@ -19600,7 +17946,7 @@
       </p:sp>
       <p:sp>
         <p:nvSpPr>
-          <p:cNvPr id="33" name="Shape 31"/>
+          <p:cNvPr id="7" name="Shape 5"/>
           <p:cNvSpPr/>
           <p:nvPr/>
         </p:nvSpPr>
@@ -19625,7 +17971,7 @@
       </p:sp>
       <p:sp>
         <p:nvSpPr>
-          <p:cNvPr id="34" name="Shape 32"/>
+          <p:cNvPr id="8" name="Shape 6"/>
           <p:cNvSpPr/>
           <p:nvPr/>
         </p:nvSpPr>
@@ -19650,7 +17996,7 @@
       </p:sp>
       <p:sp>
         <p:nvSpPr>
-          <p:cNvPr id="35" name="Shape 33"/>
+          <p:cNvPr id="9" name="Shape 7"/>
           <p:cNvSpPr/>
           <p:nvPr/>
         </p:nvSpPr>
@@ -19675,7 +18021,7 @@
       </p:sp>
       <p:sp>
         <p:nvSpPr>
-          <p:cNvPr id="36" name="Shape 34"/>
+          <p:cNvPr id="10" name="Shape 8"/>
           <p:cNvSpPr/>
           <p:nvPr/>
         </p:nvSpPr>
@@ -19700,7 +18046,7 @@
       </p:sp>
       <p:sp>
         <p:nvSpPr>
-          <p:cNvPr id="37" name="Shape 35"/>
+          <p:cNvPr id="11" name="Shape 9"/>
           <p:cNvSpPr/>
           <p:nvPr/>
         </p:nvSpPr>
@@ -19725,7 +18071,7 @@
       </p:sp>
       <p:sp>
         <p:nvSpPr>
-          <p:cNvPr id="38" name="Shape 36"/>
+          <p:cNvPr id="12" name="Shape 10"/>
           <p:cNvSpPr/>
           <p:nvPr/>
         </p:nvSpPr>
@@ -19750,7 +18096,7 @@
       </p:sp>
       <p:sp>
         <p:nvSpPr>
-          <p:cNvPr id="39" name="Shape 37"/>
+          <p:cNvPr id="13" name="Shape 11"/>
           <p:cNvSpPr/>
           <p:nvPr/>
         </p:nvSpPr>
@@ -19770,7 +18116,7 @@
       </p:sp>
       <p:sp>
         <p:nvSpPr>
-          <p:cNvPr id="40" name="Text 38"/>
+          <p:cNvPr id="14" name="Text 12"/>
           <p:cNvSpPr/>
           <p:nvPr/>
         </p:nvSpPr>
@@ -19886,7 +18232,1122 @@
       </p:sp>
       <p:sp>
         <p:nvSpPr>
-          <p:cNvPr id="41" name="Shape 39"/>
+          <p:cNvPr id="15" name="Text 13"/>
+          <p:cNvSpPr/>
+          <p:nvPr/>
+        </p:nvSpPr>
+        <p:spPr>
+          <a:xfrm>
+            <a:off x="914400" y="952500"/>
+            <a:ext cx="8572500" cy="323850"/>
+          </a:xfrm>
+          <a:prstGeom prst="rect">
+            <a:avLst/>
+          </a:prstGeom>
+          <a:noFill/>
+          <a:ln/>
+        </p:spPr>
+        <p:txBody>
+          <a:bodyPr wrap="square" lIns="0" tIns="0" rIns="0" bIns="0" rtlCol="0" anchor="t"/>
+          <a:lstStyle/>
+          <a:p>
+            <a:pPr algn="l" indent="0" marL="0">
+              <a:buNone/>
+            </a:pPr>
+            <a:r>
+              <a:rPr lang="en-US" sz="1800" b="1" spc="300" kern="0" dirty="0">
+                <a:solidFill>
+                  <a:srgbClr val="0F766E"/>
+                </a:solidFill>
+                <a:latin typeface="Be Vietnam Pro" pitchFamily="34" charset="0"/>
+                <a:ea typeface="Be Vietnam Pro" pitchFamily="34" charset="-122"/>
+                <a:cs typeface="Be Vietnam Pro" pitchFamily="34" charset="-120"/>
+              </a:rPr>
+              <a:t>NHÌN</a:t>
+            </a:r>
+            <a:r>
+              <a:rPr lang="en-US" sz="1800" b="1" spc="302" kern="0" dirty="0">
+                <a:solidFill>
+                  <a:srgbClr val="0F766E"/>
+                </a:solidFill>
+                <a:latin typeface="Be Vietnam Pro" pitchFamily="34" charset="0"/>
+                <a:ea typeface="Be Vietnam Pro" pitchFamily="34" charset="-122"/>
+                <a:cs typeface="Be Vietnam Pro" pitchFamily="34" charset="-120"/>
+              </a:rPr>
+              <a:t> HÌNH</a:t>
+            </a:r>
+            <a:r>
+              <a:rPr lang="en-US" sz="1800" b="1" spc="297" kern="0" dirty="0">
+                <a:solidFill>
+                  <a:srgbClr val="0F766E"/>
+                </a:solidFill>
+                <a:latin typeface="Be Vietnam Pro" pitchFamily="34" charset="0"/>
+                <a:ea typeface="Be Vietnam Pro" pitchFamily="34" charset="-122"/>
+                <a:cs typeface="Be Vietnam Pro" pitchFamily="34" charset="-120"/>
+              </a:rPr>
+              <a:t> TRẢ</a:t>
+            </a:r>
+            <a:r>
+              <a:rPr lang="en-US" sz="1800" b="1" spc="279" kern="0" dirty="0">
+                <a:solidFill>
+                  <a:srgbClr val="0F766E"/>
+                </a:solidFill>
+                <a:latin typeface="Be Vietnam Pro" pitchFamily="34" charset="0"/>
+                <a:ea typeface="Be Vietnam Pro" pitchFamily="34" charset="-122"/>
+                <a:cs typeface="Be Vietnam Pro" pitchFamily="34" charset="-120"/>
+              </a:rPr>
+              <a:t> LỜI</a:t>
+            </a:r>
+            <a:endParaRPr lang="en-US" sz="1800" dirty="0"/>
+          </a:p>
+        </p:txBody>
+      </p:sp>
+      <p:sp>
+        <p:nvSpPr>
+          <p:cNvPr id="16" name="Text 14"/>
+          <p:cNvSpPr/>
+          <p:nvPr/>
+        </p:nvSpPr>
+        <p:spPr>
+          <a:xfrm>
+            <a:off x="914400" y="1428750"/>
+            <a:ext cx="16459200" cy="1428750"/>
+          </a:xfrm>
+          <a:prstGeom prst="rect">
+            <a:avLst/>
+          </a:prstGeom>
+          <a:noFill/>
+          <a:ln/>
+        </p:spPr>
+        <p:txBody>
+          <a:bodyPr wrap="square" lIns="0" tIns="36576" rIns="0" bIns="-36576" rtlCol="0" anchor="t"/>
+          <a:lstStyle/>
+          <a:p>
+            <a:pPr algn="l" indent="0" marL="0">
+              <a:lnSpc>
+                <a:spcPts val="5184"/>
+              </a:lnSpc>
+              <a:buNone/>
+            </a:pPr>
+            <a:r>
+              <a:rPr lang="en-US" sz="4800" dirty="0" spc="-31" kern="0">
+                <a:solidFill>
+                  <a:srgbClr val="14161C"/>
+                </a:solidFill>
+                <a:latin typeface="Bricolage Grotesque ExtraBold" pitchFamily="34" charset="0"/>
+                <a:ea typeface="Bricolage Grotesque ExtraBold" pitchFamily="34" charset="-122"/>
+                <a:cs typeface="Bricolage Grotesque ExtraBold" pitchFamily="34" charset="-120"/>
+              </a:rPr>
+              <a:t>Trong</a:t>
+            </a:r>
+            <a:r>
+              <a:rPr lang="en-US" sz="4800" dirty="0" spc="-2" kern="0">
+                <a:solidFill>
+                  <a:srgbClr val="14161C"/>
+                </a:solidFill>
+                <a:latin typeface="Bricolage Grotesque ExtraBold" pitchFamily="34" charset="0"/>
+                <a:ea typeface="Bricolage Grotesque ExtraBold" pitchFamily="34" charset="-122"/>
+                <a:cs typeface="Bricolage Grotesque ExtraBold" pitchFamily="34" charset="-120"/>
+              </a:rPr>
+              <a:t> khung</a:t>
+            </a:r>
+            <a:r>
+              <a:rPr lang="en-US" sz="4800" dirty="0" spc="-1" kern="0">
+                <a:solidFill>
+                  <a:srgbClr val="14161C"/>
+                </a:solidFill>
+                <a:latin typeface="Bricolage Grotesque ExtraBold" pitchFamily="34" charset="0"/>
+                <a:ea typeface="Bricolage Grotesque ExtraBold" pitchFamily="34" charset="-122"/>
+                <a:cs typeface="Bricolage Grotesque ExtraBold" pitchFamily="34" charset="-120"/>
+              </a:rPr>
+              <a:t> 1.,</a:t>
+            </a:r>
+            <a:r>
+              <a:rPr lang="en-US" sz="4800" dirty="0" spc="1" kern="0">
+                <a:solidFill>
+                  <a:srgbClr val="14161C"/>
+                </a:solidFill>
+                <a:latin typeface="Bricolage Grotesque ExtraBold" pitchFamily="34" charset="0"/>
+                <a:ea typeface="Bricolage Grotesque ExtraBold" pitchFamily="34" charset="-122"/>
+                <a:cs typeface="Bricolage Grotesque ExtraBold" pitchFamily="34" charset="-120"/>
+              </a:rPr>
+              <a:t> A</a:t>
+            </a:r>
+            <a:r>
+              <a:rPr lang="en-US" sz="4800" dirty="0" spc="-2" kern="0">
+                <a:solidFill>
+                  <a:srgbClr val="14161C"/>
+                </a:solidFill>
+                <a:latin typeface="Bricolage Grotesque ExtraBold" pitchFamily="34" charset="0"/>
+                <a:ea typeface="Bricolage Grotesque ExtraBold" pitchFamily="34" charset="-122"/>
+                <a:cs typeface="Bricolage Grotesque ExtraBold" pitchFamily="34" charset="-120"/>
+              </a:rPr>
+              <a:t> lỗi</a:t>
+            </a:r>
+            <a:r>
+              <a:rPr lang="en-US" sz="4800" dirty="0" spc="-56" kern="0">
+                <a:solidFill>
+                  <a:srgbClr val="14161C"/>
+                </a:solidFill>
+                <a:latin typeface="Bricolage Grotesque ExtraBold" pitchFamily="34" charset="0"/>
+                <a:ea typeface="Bricolage Grotesque ExtraBold" pitchFamily="34" charset="-122"/>
+                <a:cs typeface="Bricolage Grotesque ExtraBold" pitchFamily="34" charset="-120"/>
+              </a:rPr>
+              <a:t> và</a:t>
+            </a:r>
+            <a:r>
+              <a:rPr lang="en-US" sz="4800" dirty="0" spc="3" kern="0">
+                <a:solidFill>
+                  <a:srgbClr val="14161C"/>
+                </a:solidFill>
+                <a:latin typeface="Bricolage Grotesque ExtraBold" pitchFamily="34" charset="0"/>
+                <a:ea typeface="Bricolage Grotesque ExtraBold" pitchFamily="34" charset="-122"/>
+                <a:cs typeface="Bricolage Grotesque ExtraBold" pitchFamily="34" charset="-120"/>
+              </a:rPr>
+              <a:t> B</a:t>
+            </a:r>
+            <a:r>
+              <a:rPr lang="en-US" sz="4800" dirty="0" spc="-42" kern="0">
+                <a:solidFill>
+                  <a:srgbClr val="14161C"/>
+                </a:solidFill>
+                <a:latin typeface="Bricolage Grotesque ExtraBold" pitchFamily="34" charset="0"/>
+                <a:ea typeface="Bricolage Grotesque ExtraBold" pitchFamily="34" charset="-122"/>
+                <a:cs typeface="Bricolage Grotesque ExtraBold" pitchFamily="34" charset="-120"/>
+              </a:rPr>
+              <a:t> vẫn</a:t>
+            </a:r>
+            <a:r>
+              <a:rPr lang="en-US" sz="4800" dirty="0" spc="-1" kern="0">
+                <a:solidFill>
+                  <a:srgbClr val="14161C"/>
+                </a:solidFill>
+                <a:latin typeface="Bricolage Grotesque ExtraBold" pitchFamily="34" charset="0"/>
+                <a:ea typeface="Bricolage Grotesque ExtraBold" pitchFamily="34" charset="-122"/>
+                <a:cs typeface="Bricolage Grotesque ExtraBold" pitchFamily="34" charset="-120"/>
+              </a:rPr>
+              <a:t> khỏe:</a:t>
+            </a:r>
+            <a:r>
+              <a:rPr lang="en-US" sz="4800" dirty="0" spc="-2" kern="0">
+                <a:solidFill>
+                  <a:srgbClr val="14161C"/>
+                </a:solidFill>
+                <a:latin typeface="Bricolage Grotesque ExtraBold" pitchFamily="34" charset="0"/>
+                <a:ea typeface="Bricolage Grotesque ExtraBold" pitchFamily="34" charset="-122"/>
+                <a:cs typeface="Bricolage Grotesque ExtraBold" pitchFamily="34" charset="-120"/>
+              </a:rPr>
+              <a:t> </a:t>
+            </a:r>
+            <a:pPr algn="l" indent="0" marL="0">
+              <a:lnSpc>
+                <a:spcPts val="5184"/>
+              </a:lnSpc>
+              <a:buNone/>
+            </a:pPr>
+            <a:r>
+              <a:rPr lang="en-US" sz="4800" dirty="0" spc="0" kern="0">
+                <a:solidFill>
+                  <a:srgbClr val="0F766E"/>
+                </a:solidFill>
+                <a:latin typeface="Bricolage Grotesque ExtraBold" pitchFamily="34" charset="0"/>
+                <a:ea typeface="Bricolage Grotesque ExtraBold" pitchFamily="34" charset="-122"/>
+                <a:cs typeface="Bricolage Grotesque ExtraBold" pitchFamily="34" charset="-120"/>
+              </a:rPr>
+              <a:t>mũi</a:t>
+            </a:r>
+            <a:r>
+              <a:rPr lang="en-US" sz="4800" dirty="0" spc="-14" kern="0">
+                <a:solidFill>
+                  <a:srgbClr val="0F766E"/>
+                </a:solidFill>
+                <a:latin typeface="Bricolage Grotesque ExtraBold" pitchFamily="34" charset="0"/>
+                <a:ea typeface="Bricolage Grotesque ExtraBold" pitchFamily="34" charset="-122"/>
+                <a:cs typeface="Bricolage Grotesque ExtraBold" pitchFamily="34" charset="-120"/>
+              </a:rPr>
+              <a:t> tên</a:t>
+            </a:r>
+            <a:r>
+              <a:rPr lang="en-US" sz="4800" dirty="0" spc="-4" kern="0">
+                <a:solidFill>
+                  <a:srgbClr val="0F766E"/>
+                </a:solidFill>
+                <a:latin typeface="Bricolage Grotesque ExtraBold" pitchFamily="34" charset="0"/>
+                <a:ea typeface="Bricolage Grotesque ExtraBold" pitchFamily="34" charset="-122"/>
+                <a:cs typeface="Bricolage Grotesque ExtraBold" pitchFamily="34" charset="-120"/>
+              </a:rPr>
+              <a:t> request</a:t>
+            </a:r>
+            <a:r>
+              <a:rPr lang="en-US" sz="4800" dirty="0" spc="-23" kern="0">
+                <a:solidFill>
+                  <a:srgbClr val="0F766E"/>
+                </a:solidFill>
+                <a:latin typeface="Bricolage Grotesque ExtraBold" pitchFamily="34" charset="0"/>
+                <a:ea typeface="Bricolage Grotesque ExtraBold" pitchFamily="34" charset="-122"/>
+                <a:cs typeface="Bricolage Grotesque ExtraBold" pitchFamily="34" charset="-120"/>
+              </a:rPr>
+              <a:t> mới</a:t>
+            </a:r>
+            <a:r>
+              <a:rPr lang="en-US" sz="4800" dirty="0" spc="25" kern="0">
+                <a:solidFill>
+                  <a:srgbClr val="0F766E"/>
+                </a:solidFill>
+                <a:latin typeface="Bricolage Grotesque ExtraBold" pitchFamily="34" charset="0"/>
+                <a:ea typeface="Bricolage Grotesque ExtraBold" pitchFamily="34" charset="-122"/>
+                <a:cs typeface="Bricolage Grotesque ExtraBold" pitchFamily="34" charset="-120"/>
+              </a:rPr>
+              <a:t> đi</a:t>
+            </a:r>
+            <a:r>
+              <a:rPr lang="en-US" sz="4800" dirty="0" spc="-44" kern="0">
+                <a:solidFill>
+                  <a:srgbClr val="0F766E"/>
+                </a:solidFill>
+                <a:latin typeface="Bricolage Grotesque ExtraBold" pitchFamily="34" charset="0"/>
+                <a:ea typeface="Bricolage Grotesque ExtraBold" pitchFamily="34" charset="-122"/>
+                <a:cs typeface="Bricolage Grotesque ExtraBold" pitchFamily="34" charset="-120"/>
+              </a:rPr>
+              <a:t> tới</a:t>
+            </a:r>
+            <a:r>
+              <a:rPr lang="en-US" sz="4800" dirty="0" spc="0" kern="0">
+                <a:solidFill>
+                  <a:srgbClr val="0F766E"/>
+                </a:solidFill>
+                <a:latin typeface="Bricolage Grotesque ExtraBold" pitchFamily="34" charset="0"/>
+                <a:ea typeface="Bricolage Grotesque ExtraBold" pitchFamily="34" charset="-122"/>
+                <a:cs typeface="Bricolage Grotesque ExtraBold" pitchFamily="34" charset="-120"/>
+              </a:rPr>
+              <a:t> máy</a:t>
+            </a:r>
+            <a:r>
+              <a:rPr lang="en-US" sz="4800" dirty="0" spc="-29" kern="0">
+                <a:solidFill>
+                  <a:srgbClr val="0F766E"/>
+                </a:solidFill>
+                <a:latin typeface="Bricolage Grotesque ExtraBold" pitchFamily="34" charset="0"/>
+                <a:ea typeface="Bricolage Grotesque ExtraBold" pitchFamily="34" charset="-122"/>
+                <a:cs typeface="Bricolage Grotesque ExtraBold" pitchFamily="34" charset="-120"/>
+              </a:rPr>
+              <a:t> nào?</a:t>
+            </a:r>
+            <a:endParaRPr lang="en-US" sz="4800" dirty="0"/>
+          </a:p>
+        </p:txBody>
+      </p:sp>
+      <p:sp>
+        <p:nvSpPr>
+          <p:cNvPr id="17" name="Text 15"/>
+          <p:cNvSpPr/>
+          <p:nvPr/>
+        </p:nvSpPr>
+        <p:spPr>
+          <a:xfrm>
+            <a:off x="914400" y="4286250"/>
+            <a:ext cx="3143250" cy="800100"/>
+          </a:xfrm>
+          <a:prstGeom prst="roundRect">
+            <a:avLst>
+              <a:gd name="adj" fmla="val 50000"/>
+            </a:avLst>
+          </a:prstGeom>
+          <a:solidFill>
+            <a:srgbClr val="14161C"/>
+          </a:solidFill>
+          <a:ln/>
+        </p:spPr>
+        <p:txBody>
+          <a:bodyPr wrap="square" lIns="0" tIns="0" rIns="0" bIns="0" rtlCol="0" anchor="ctr"/>
+          <a:lstStyle/>
+          <a:p>
+            <a:pPr algn="ctr" indent="0" marL="0">
+              <a:buNone/>
+            </a:pPr>
+            <a:r>
+              <a:rPr lang="en-US" sz="2550" b="1" dirty="0" spc="-14" kern="0">
+                <a:solidFill>
+                  <a:srgbClr val="F3EEE3"/>
+                </a:solidFill>
+                <a:latin typeface="Be Vietnam Pro" pitchFamily="34" charset="0"/>
+                <a:ea typeface="Be Vietnam Pro" pitchFamily="34" charset="-122"/>
+                <a:cs typeface="Be Vietnam Pro" pitchFamily="34" charset="-120"/>
+              </a:rPr>
+              <a:t>request</a:t>
+            </a:r>
+            <a:r>
+              <a:rPr lang="en-US" sz="2550" b="1" dirty="0" spc="3" kern="0">
+                <a:solidFill>
+                  <a:srgbClr val="F3EEE3"/>
+                </a:solidFill>
+                <a:latin typeface="Be Vietnam Pro" pitchFamily="34" charset="0"/>
+                <a:ea typeface="Be Vietnam Pro" pitchFamily="34" charset="-122"/>
+                <a:cs typeface="Be Vietnam Pro" pitchFamily="34" charset="-120"/>
+              </a:rPr>
+              <a:t> mới</a:t>
+            </a:r>
+            <a:endParaRPr lang="en-US" sz="2550" dirty="0"/>
+          </a:p>
+        </p:txBody>
+      </p:sp>
+      <p:sp>
+        <p:nvSpPr>
+          <p:cNvPr id="18" name="Connector line-1792321778022-430965913"/>
+          <p:cNvSpPr/>
+          <p:nvPr/>
+        </p:nvSpPr>
+        <p:spPr>
+          <a:xfrm>
+            <a:off x="4191000" y="4686300"/>
+            <a:ext cx="1238250" cy="0"/>
+          </a:xfrm>
+          <a:prstGeom prst="line">
+            <a:avLst/>
+          </a:prstGeom>
+          <a:noFill/>
+          <a:ln w="57150">
+            <a:solidFill>
+              <a:srgbClr val="14161C"/>
+            </a:solidFill>
+            <a:prstDash val="solid"/>
+            <a:headEnd type="none"/>
+            <a:tailEnd type="triangle"/>
+          </a:ln>
+        </p:spPr>
+      </p:sp>
+      <p:sp>
+        <p:nvSpPr>
+          <p:cNvPr id="19" name="Text 17"/>
+          <p:cNvSpPr/>
+          <p:nvPr/>
+        </p:nvSpPr>
+        <p:spPr>
+          <a:xfrm>
+            <a:off x="5619750" y="4114800"/>
+            <a:ext cx="1905000" cy="1143000"/>
+          </a:xfrm>
+          <a:prstGeom prst="roundRect">
+            <a:avLst>
+              <a:gd name="adj" fmla="val 23333"/>
+            </a:avLst>
+          </a:prstGeom>
+          <a:solidFill>
+            <a:srgbClr val="14161C"/>
+          </a:solidFill>
+          <a:ln/>
+        </p:spPr>
+        <p:txBody>
+          <a:bodyPr wrap="square" lIns="0" tIns="0" rIns="0" bIns="0" rtlCol="0" anchor="ctr"/>
+          <a:lstStyle/>
+          <a:p>
+            <a:pPr algn="ctr" indent="0" marL="0">
+              <a:buNone/>
+            </a:pPr>
+            <a:r>
+              <a:rPr lang="en-US" sz="4500" dirty="0" spc="-3" kern="0">
+                <a:solidFill>
+                  <a:srgbClr val="F3EEE3"/>
+                </a:solidFill>
+                <a:latin typeface="Bricolage Grotesque ExtraBold" pitchFamily="34" charset="0"/>
+                <a:ea typeface="Bricolage Grotesque ExtraBold" pitchFamily="34" charset="-122"/>
+                <a:cs typeface="Bricolage Grotesque ExtraBold" pitchFamily="34" charset="-120"/>
+              </a:rPr>
+              <a:t>LB</a:t>
+            </a:r>
+            <a:endParaRPr lang="en-US" sz="4500" dirty="0"/>
+          </a:p>
+        </p:txBody>
+      </p:sp>
+      <p:sp>
+        <p:nvSpPr>
+          <p:cNvPr id="20" name="Connector line-1792321778025-259821221"/>
+          <p:cNvSpPr/>
+          <p:nvPr/>
+        </p:nvSpPr>
+        <p:spPr>
+          <a:xfrm flipV="1">
+            <a:off x="7677150" y="3905250"/>
+            <a:ext cx="1657350" cy="571500"/>
+          </a:xfrm>
+          <a:prstGeom prst="line">
+            <a:avLst/>
+          </a:prstGeom>
+          <a:noFill/>
+          <a:ln w="57150">
+            <a:solidFill>
+              <a:srgbClr val="E8472B"/>
+            </a:solidFill>
+            <a:prstDash val="solid"/>
+            <a:headEnd type="none"/>
+            <a:tailEnd type="triangle"/>
+          </a:ln>
+        </p:spPr>
+      </p:sp>
+      <p:sp>
+        <p:nvSpPr>
+          <p:cNvPr id="21" name="Connector line-1792321778025-707898227"/>
+          <p:cNvSpPr/>
+          <p:nvPr/>
+        </p:nvSpPr>
+        <p:spPr>
+          <a:xfrm>
+            <a:off x="7677150" y="4895850"/>
+            <a:ext cx="1657350" cy="571500"/>
+          </a:xfrm>
+          <a:prstGeom prst="line">
+            <a:avLst/>
+          </a:prstGeom>
+          <a:noFill/>
+          <a:ln w="57150">
+            <a:solidFill>
+              <a:srgbClr val="0F766E"/>
+            </a:solidFill>
+            <a:prstDash val="solid"/>
+            <a:headEnd type="none"/>
+            <a:tailEnd type="triangle"/>
+          </a:ln>
+        </p:spPr>
+      </p:sp>
+      <p:sp>
+        <p:nvSpPr>
+          <p:cNvPr id="22" name="Shape 20"/>
+          <p:cNvSpPr/>
+          <p:nvPr/>
+        </p:nvSpPr>
+        <p:spPr>
+          <a:xfrm>
+            <a:off x="9525000" y="3238500"/>
+            <a:ext cx="6096000" cy="1333500"/>
+          </a:xfrm>
+          <a:prstGeom prst="roundRect">
+            <a:avLst>
+              <a:gd name="adj" fmla="val 20000"/>
+            </a:avLst>
+          </a:prstGeom>
+          <a:solidFill>
+            <a:srgbClr val="F8D9D0"/>
+          </a:solidFill>
+          <a:ln/>
+        </p:spPr>
+      </p:sp>
+      <p:sp>
+        <p:nvSpPr>
+          <p:cNvPr id="23" name="Shape 21"/>
+          <p:cNvSpPr/>
+          <p:nvPr/>
+        </p:nvSpPr>
+        <p:spPr>
+          <a:xfrm>
+            <a:off x="9525000" y="4800600"/>
+            <a:ext cx="6096000" cy="1333500"/>
+          </a:xfrm>
+          <a:prstGeom prst="roundRect">
+            <a:avLst>
+              <a:gd name="adj" fmla="val 20000"/>
+            </a:avLst>
+          </a:prstGeom>
+          <a:solidFill>
+            <a:srgbClr val="CFE8E2"/>
+          </a:solidFill>
+          <a:ln/>
+        </p:spPr>
+      </p:sp>
+      <p:sp>
+        <p:nvSpPr>
+          <p:cNvPr id="24" name="Text 22"/>
+          <p:cNvSpPr/>
+          <p:nvPr/>
+        </p:nvSpPr>
+        <p:spPr>
+          <a:xfrm>
+            <a:off x="9906000" y="3486150"/>
+            <a:ext cx="3143250" cy="838200"/>
+          </a:xfrm>
+          <a:prstGeom prst="rect">
+            <a:avLst/>
+          </a:prstGeom>
+          <a:noFill/>
+          <a:ln/>
+        </p:spPr>
+        <p:txBody>
+          <a:bodyPr wrap="square" lIns="0" tIns="0" rIns="0" bIns="0" rtlCol="0" anchor="ctr"/>
+          <a:lstStyle/>
+          <a:p>
+            <a:pPr algn="l" indent="0" marL="0">
+              <a:buNone/>
+            </a:pPr>
+            <a:r>
+              <a:rPr lang="en-US" sz="4200" dirty="0" spc="3" kern="0">
+                <a:solidFill>
+                  <a:srgbClr val="E8472B"/>
+                </a:solidFill>
+                <a:latin typeface="Bricolage Grotesque ExtraBold" pitchFamily="34" charset="0"/>
+                <a:ea typeface="Bricolage Grotesque ExtraBold" pitchFamily="34" charset="-122"/>
+                <a:cs typeface="Bricolage Grotesque ExtraBold" pitchFamily="34" charset="-120"/>
+              </a:rPr>
+              <a:t>Máy</a:t>
+            </a:r>
+            <a:r>
+              <a:rPr lang="en-US" sz="4200" dirty="0" spc="4" kern="0">
+                <a:solidFill>
+                  <a:srgbClr val="E8472B"/>
+                </a:solidFill>
+                <a:latin typeface="Bricolage Grotesque ExtraBold" pitchFamily="34" charset="0"/>
+                <a:ea typeface="Bricolage Grotesque ExtraBold" pitchFamily="34" charset="-122"/>
+                <a:cs typeface="Bricolage Grotesque ExtraBold" pitchFamily="34" charset="-120"/>
+              </a:rPr>
+              <a:t> A</a:t>
+            </a:r>
+            <a:endParaRPr lang="en-US" sz="4200" dirty="0"/>
+          </a:p>
+        </p:txBody>
+      </p:sp>
+      <p:sp>
+        <p:nvSpPr>
+          <p:cNvPr id="25" name="Text 23"/>
+          <p:cNvSpPr/>
+          <p:nvPr/>
+        </p:nvSpPr>
+        <p:spPr>
+          <a:xfrm>
+            <a:off x="9906000" y="5048250"/>
+            <a:ext cx="3143250" cy="838200"/>
+          </a:xfrm>
+          <a:prstGeom prst="rect">
+            <a:avLst/>
+          </a:prstGeom>
+          <a:noFill/>
+          <a:ln/>
+        </p:spPr>
+        <p:txBody>
+          <a:bodyPr wrap="square" lIns="0" tIns="0" rIns="0" bIns="0" rtlCol="0" anchor="ctr"/>
+          <a:lstStyle/>
+          <a:p>
+            <a:pPr algn="l" indent="0" marL="0">
+              <a:buNone/>
+            </a:pPr>
+            <a:r>
+              <a:rPr lang="en-US" sz="4200" dirty="0" spc="3" kern="0">
+                <a:solidFill>
+                  <a:srgbClr val="0F766E"/>
+                </a:solidFill>
+                <a:latin typeface="Bricolage Grotesque ExtraBold" pitchFamily="34" charset="0"/>
+                <a:ea typeface="Bricolage Grotesque ExtraBold" pitchFamily="34" charset="-122"/>
+                <a:cs typeface="Bricolage Grotesque ExtraBold" pitchFamily="34" charset="-120"/>
+              </a:rPr>
+              <a:t>Máy B</a:t>
+            </a:r>
+            <a:endParaRPr lang="en-US" sz="4200" dirty="0"/>
+          </a:p>
+        </p:txBody>
+      </p:sp>
+      <p:sp>
+        <p:nvSpPr>
+          <p:cNvPr id="26" name="Text 24"/>
+          <p:cNvSpPr/>
+          <p:nvPr/>
+        </p:nvSpPr>
+        <p:spPr>
+          <a:xfrm>
+            <a:off x="13335000" y="3733800"/>
+            <a:ext cx="1905000" cy="533400"/>
+          </a:xfrm>
+          <a:prstGeom prst="roundRect">
+            <a:avLst>
+              <a:gd name="adj" fmla="val 50000"/>
+            </a:avLst>
+          </a:prstGeom>
+          <a:solidFill>
+            <a:srgbClr val="E8472B"/>
+          </a:solidFill>
+          <a:ln/>
+        </p:spPr>
+        <p:txBody>
+          <a:bodyPr wrap="square" lIns="0" tIns="0" rIns="0" bIns="0" rtlCol="0" anchor="ctr"/>
+          <a:lstStyle/>
+          <a:p>
+            <a:pPr algn="ctr" indent="0" marL="0">
+              <a:buNone/>
+            </a:pPr>
+            <a:r>
+              <a:rPr lang="en-US" sz="2250" b="1" dirty="0" spc="-2" kern="0">
+                <a:solidFill>
+                  <a:srgbClr val="FFFFFF"/>
+                </a:solidFill>
+                <a:latin typeface="Be Vietnam Pro" pitchFamily="34" charset="0"/>
+                <a:ea typeface="Be Vietnam Pro" pitchFamily="34" charset="-122"/>
+                <a:cs typeface="Be Vietnam Pro" pitchFamily="34" charset="-120"/>
+              </a:rPr>
+              <a:t>lỗi</a:t>
+            </a:r>
+            <a:endParaRPr lang="en-US" sz="2250" dirty="0"/>
+          </a:p>
+        </p:txBody>
+      </p:sp>
+      <p:sp>
+        <p:nvSpPr>
+          <p:cNvPr id="27" name="Text 25"/>
+          <p:cNvSpPr/>
+          <p:nvPr/>
+        </p:nvSpPr>
+        <p:spPr>
+          <a:xfrm>
+            <a:off x="13335000" y="5295900"/>
+            <a:ext cx="1905000" cy="533400"/>
+          </a:xfrm>
+          <a:prstGeom prst="roundRect">
+            <a:avLst>
+              <a:gd name="adj" fmla="val 50000"/>
+            </a:avLst>
+          </a:prstGeom>
+          <a:solidFill>
+            <a:srgbClr val="0F766E"/>
+          </a:solidFill>
+          <a:ln/>
+        </p:spPr>
+        <p:txBody>
+          <a:bodyPr wrap="square" lIns="0" tIns="0" rIns="0" bIns="0" rtlCol="0" anchor="ctr"/>
+          <a:lstStyle/>
+          <a:p>
+            <a:pPr algn="ctr" indent="0" marL="0">
+              <a:buNone/>
+            </a:pPr>
+            <a:r>
+              <a:rPr lang="en-US" sz="2250" b="1" dirty="0" spc="-18" kern="0">
+                <a:solidFill>
+                  <a:srgbClr val="FFFFFF"/>
+                </a:solidFill>
+                <a:latin typeface="Be Vietnam Pro" pitchFamily="34" charset="0"/>
+                <a:ea typeface="Be Vietnam Pro" pitchFamily="34" charset="-122"/>
+                <a:cs typeface="Be Vietnam Pro" pitchFamily="34" charset="-120"/>
+              </a:rPr>
+              <a:t>vẫn</a:t>
+            </a:r>
+            <a:r>
+              <a:rPr lang="en-US" sz="2250" b="1" dirty="0" spc="-1" kern="0">
+                <a:solidFill>
+                  <a:srgbClr val="FFFFFF"/>
+                </a:solidFill>
+                <a:latin typeface="Be Vietnam Pro" pitchFamily="34" charset="0"/>
+                <a:ea typeface="Be Vietnam Pro" pitchFamily="34" charset="-122"/>
+                <a:cs typeface="Be Vietnam Pro" pitchFamily="34" charset="-120"/>
+              </a:rPr>
+              <a:t> khỏe</a:t>
+            </a:r>
+            <a:endParaRPr lang="en-US" sz="2250" dirty="0"/>
+          </a:p>
+        </p:txBody>
+      </p:sp>
+      <p:sp>
+        <p:nvSpPr>
+          <p:cNvPr id="28" name="Shape 26"/>
+          <p:cNvSpPr/>
+          <p:nvPr/>
+        </p:nvSpPr>
+        <p:spPr>
+          <a:xfrm>
+            <a:off x="914400" y="6667500"/>
+            <a:ext cx="16459200" cy="2095500"/>
+          </a:xfrm>
+          <a:prstGeom prst="roundRect">
+            <a:avLst>
+              <a:gd name="adj" fmla="val 21818"/>
+            </a:avLst>
+          </a:prstGeom>
+          <a:solidFill>
+            <a:srgbClr val="14161C"/>
+          </a:solidFill>
+          <a:ln/>
+        </p:spPr>
+      </p:sp>
+      <p:sp>
+        <p:nvSpPr>
+          <p:cNvPr id="29" name="Text 27"/>
+          <p:cNvSpPr/>
+          <p:nvPr/>
+        </p:nvSpPr>
+        <p:spPr>
+          <a:xfrm>
+            <a:off x="1428750" y="6972300"/>
+            <a:ext cx="6667500" cy="285750"/>
+          </a:xfrm>
+          <a:prstGeom prst="rect">
+            <a:avLst/>
+          </a:prstGeom>
+          <a:noFill/>
+          <a:ln/>
+        </p:spPr>
+        <p:txBody>
+          <a:bodyPr wrap="square" lIns="0" tIns="0" rIns="0" bIns="0" rtlCol="0" anchor="t"/>
+          <a:lstStyle/>
+          <a:p>
+            <a:pPr algn="l" indent="0" marL="0">
+              <a:buNone/>
+            </a:pPr>
+            <a:r>
+              <a:rPr lang="en-US" sz="1650" b="1" spc="201" kern="0" dirty="0">
+                <a:solidFill>
+                  <a:srgbClr val="3DD6A0"/>
+                </a:solidFill>
+                <a:latin typeface="Be Vietnam Pro" pitchFamily="34" charset="0"/>
+                <a:ea typeface="Be Vietnam Pro" pitchFamily="34" charset="-122"/>
+                <a:cs typeface="Be Vietnam Pro" pitchFamily="34" charset="-120"/>
+              </a:rPr>
+              <a:t>ĐÁP</a:t>
+            </a:r>
+            <a:r>
+              <a:rPr lang="en-US" sz="1650" b="1" spc="224" kern="0" dirty="0">
+                <a:solidFill>
+                  <a:srgbClr val="3DD6A0"/>
+                </a:solidFill>
+                <a:latin typeface="Be Vietnam Pro" pitchFamily="34" charset="0"/>
+                <a:ea typeface="Be Vietnam Pro" pitchFamily="34" charset="-122"/>
+                <a:cs typeface="Be Vietnam Pro" pitchFamily="34" charset="-120"/>
+              </a:rPr>
+              <a:t> ÁN</a:t>
+            </a:r>
+            <a:endParaRPr lang="en-US" sz="1650" dirty="0"/>
+          </a:p>
+        </p:txBody>
+      </p:sp>
+      <p:sp>
+        <p:nvSpPr>
+          <p:cNvPr id="30" name="Text 28"/>
+          <p:cNvSpPr/>
+          <p:nvPr/>
+        </p:nvSpPr>
+        <p:spPr>
+          <a:xfrm>
+            <a:off x="1428750" y="7429500"/>
+            <a:ext cx="15430500" cy="1143000"/>
+          </a:xfrm>
+          <a:prstGeom prst="rect">
+            <a:avLst/>
+          </a:prstGeom>
+          <a:noFill/>
+          <a:ln/>
+        </p:spPr>
+        <p:txBody>
+          <a:bodyPr wrap="square" lIns="0" tIns="20955" rIns="0" bIns="-20955" rtlCol="0" anchor="t"/>
+          <a:lstStyle/>
+          <a:p>
+            <a:pPr algn="l" indent="0" marL="0">
+              <a:lnSpc>
+                <a:spcPts val="3750"/>
+              </a:lnSpc>
+              <a:buNone/>
+            </a:pPr>
+            <a:r>
+              <a:rPr lang="en-US" sz="3000" b="1" dirty="0" spc="-16" kern="0">
+                <a:solidFill>
+                  <a:srgbClr val="3DD6A0"/>
+                </a:solidFill>
+                <a:latin typeface="Be Vietnam Pro" pitchFamily="34" charset="0"/>
+                <a:ea typeface="Be Vietnam Pro" pitchFamily="34" charset="-122"/>
+                <a:cs typeface="Be Vietnam Pro" pitchFamily="34" charset="-120"/>
+              </a:rPr>
+              <a:t>Máy</a:t>
+            </a:r>
+            <a:r>
+              <a:rPr lang="en-US" sz="3000" b="1" dirty="0" spc="3" kern="0">
+                <a:solidFill>
+                  <a:srgbClr val="3DD6A0"/>
+                </a:solidFill>
+                <a:latin typeface="Be Vietnam Pro" pitchFamily="34" charset="0"/>
+                <a:ea typeface="Be Vietnam Pro" pitchFamily="34" charset="-122"/>
+                <a:cs typeface="Be Vietnam Pro" pitchFamily="34" charset="-120"/>
+              </a:rPr>
+              <a:t> B.</a:t>
+            </a:r>
+            <a:pPr algn="l" indent="0" marL="0">
+              <a:lnSpc>
+                <a:spcPts val="3750"/>
+              </a:lnSpc>
+              <a:buNone/>
+            </a:pPr>
+            <a:r>
+              <a:rPr lang="en-US" sz="3000" b="1" dirty="0" spc="8" kern="0">
+                <a:solidFill>
+                  <a:srgbClr val="F3EEE3"/>
+                </a:solidFill>
+                <a:latin typeface="Be Vietnam Pro" pitchFamily="34" charset="0"/>
+                <a:ea typeface="Be Vietnam Pro" pitchFamily="34" charset="-122"/>
+                <a:cs typeface="Be Vietnam Pro" pitchFamily="34" charset="-120"/>
+              </a:rPr>
+              <a:t> Đường</a:t>
+            </a:r>
+            <a:r>
+              <a:rPr lang="en-US" sz="3000" b="1" dirty="0" spc="1" kern="0">
+                <a:solidFill>
+                  <a:srgbClr val="F3EEE3"/>
+                </a:solidFill>
+                <a:latin typeface="Be Vietnam Pro" pitchFamily="34" charset="0"/>
+                <a:ea typeface="Be Vietnam Pro" pitchFamily="34" charset="-122"/>
+                <a:cs typeface="Be Vietnam Pro" pitchFamily="34" charset="-120"/>
+              </a:rPr>
+              <a:t> tới</a:t>
+            </a:r>
+            <a:r>
+              <a:rPr lang="en-US" sz="3000" b="1" dirty="0" spc="-2" kern="0">
+                <a:solidFill>
+                  <a:srgbClr val="F3EEE3"/>
+                </a:solidFill>
+                <a:latin typeface="Be Vietnam Pro" pitchFamily="34" charset="0"/>
+                <a:ea typeface="Be Vietnam Pro" pitchFamily="34" charset="-122"/>
+                <a:cs typeface="Be Vietnam Pro" pitchFamily="34" charset="-120"/>
+              </a:rPr>
+              <a:t> A</a:t>
+            </a:r>
+            <a:r>
+              <a:rPr lang="en-US" sz="3000" b="1" dirty="0" spc="4" kern="0">
+                <a:solidFill>
+                  <a:srgbClr val="F3EEE3"/>
+                </a:solidFill>
+                <a:latin typeface="Be Vietnam Pro" pitchFamily="34" charset="0"/>
+                <a:ea typeface="Be Vietnam Pro" pitchFamily="34" charset="-122"/>
+                <a:cs typeface="Be Vietnam Pro" pitchFamily="34" charset="-120"/>
+              </a:rPr>
+              <a:t> bị</a:t>
+            </a:r>
+            <a:r>
+              <a:rPr lang="en-US" sz="3000" b="1" dirty="0" spc="0" kern="0">
+                <a:solidFill>
+                  <a:srgbClr val="F3EEE3"/>
+                </a:solidFill>
+                <a:latin typeface="Be Vietnam Pro" pitchFamily="34" charset="0"/>
+                <a:ea typeface="Be Vietnam Pro" pitchFamily="34" charset="-122"/>
+                <a:cs typeface="Be Vietnam Pro" pitchFamily="34" charset="-120"/>
+              </a:rPr>
+              <a:t> gạch</a:t>
+            </a:r>
+            <a:r>
+              <a:rPr lang="en-US" sz="3000" b="1" dirty="0" spc="-1" kern="0">
+                <a:solidFill>
+                  <a:srgbClr val="F3EEE3"/>
+                </a:solidFill>
+                <a:latin typeface="Be Vietnam Pro" pitchFamily="34" charset="0"/>
+                <a:ea typeface="Be Vietnam Pro" pitchFamily="34" charset="-122"/>
+                <a:cs typeface="Be Vietnam Pro" pitchFamily="34" charset="-120"/>
+              </a:rPr>
+              <a:t> bỏ. Hình</a:t>
+            </a:r>
+            <a:r>
+              <a:rPr lang="en-US" sz="3000" b="1" dirty="0" spc="-5" kern="0">
+                <a:solidFill>
+                  <a:srgbClr val="F3EEE3"/>
+                </a:solidFill>
+                <a:latin typeface="Be Vietnam Pro" pitchFamily="34" charset="0"/>
+                <a:ea typeface="Be Vietnam Pro" pitchFamily="34" charset="-122"/>
+                <a:cs typeface="Be Vietnam Pro" pitchFamily="34" charset="-120"/>
+              </a:rPr>
+              <a:t> mô</a:t>
+            </a:r>
+            <a:r>
+              <a:rPr lang="en-US" sz="3000" b="1" dirty="0" spc="-6" kern="0">
+                <a:solidFill>
+                  <a:srgbClr val="F3EEE3"/>
+                </a:solidFill>
+                <a:latin typeface="Be Vietnam Pro" pitchFamily="34" charset="0"/>
+                <a:ea typeface="Be Vietnam Pro" pitchFamily="34" charset="-122"/>
+                <a:cs typeface="Be Vietnam Pro" pitchFamily="34" charset="-120"/>
+              </a:rPr>
+              <a:t> tả</a:t>
+            </a:r>
+            <a:r>
+              <a:rPr lang="en-US" sz="3000" b="1" dirty="0" spc="-18" kern="0">
+                <a:solidFill>
+                  <a:srgbClr val="F3EEE3"/>
+                </a:solidFill>
+                <a:latin typeface="Be Vietnam Pro" pitchFamily="34" charset="0"/>
+                <a:ea typeface="Be Vietnam Pro" pitchFamily="34" charset="-122"/>
+                <a:cs typeface="Be Vietnam Pro" pitchFamily="34" charset="-120"/>
+              </a:rPr>
+              <a:t> quyết</a:t>
+            </a:r>
+            <a:r>
+              <a:rPr lang="en-US" sz="3000" b="1" dirty="0" spc="17" kern="0">
+                <a:solidFill>
+                  <a:srgbClr val="F3EEE3"/>
+                </a:solidFill>
+                <a:latin typeface="Be Vietnam Pro" pitchFamily="34" charset="0"/>
+                <a:ea typeface="Be Vietnam Pro" pitchFamily="34" charset="-122"/>
+                <a:cs typeface="Be Vietnam Pro" pitchFamily="34" charset="-120"/>
+              </a:rPr>
+              <a:t> định</a:t>
+            </a:r>
+            <a:r>
+              <a:rPr lang="en-US" sz="3000" b="1" dirty="0" spc="-4" kern="0">
+                <a:solidFill>
+                  <a:srgbClr val="F3EEE3"/>
+                </a:solidFill>
+                <a:latin typeface="Be Vietnam Pro" pitchFamily="34" charset="0"/>
+                <a:ea typeface="Be Vietnam Pro" pitchFamily="34" charset="-122"/>
+                <a:cs typeface="Be Vietnam Pro" pitchFamily="34" charset="-120"/>
+              </a:rPr>
+              <a:t> cho</a:t>
+            </a:r>
+            <a:r>
+              <a:rPr lang="en-US" sz="3000" b="1" dirty="0" spc="-12" kern="0">
+                <a:solidFill>
+                  <a:srgbClr val="F3EEE3"/>
+                </a:solidFill>
+                <a:latin typeface="Be Vietnam Pro" pitchFamily="34" charset="0"/>
+                <a:ea typeface="Be Vietnam Pro" pitchFamily="34" charset="-122"/>
+                <a:cs typeface="Be Vietnam Pro" pitchFamily="34" charset="-120"/>
+              </a:rPr>
+              <a:t> request</a:t>
+            </a:r>
+            <a:r>
+              <a:rPr lang="en-US" sz="3000" b="1" dirty="0" spc="2" kern="0">
+                <a:solidFill>
+                  <a:srgbClr val="F3EEE3"/>
+                </a:solidFill>
+                <a:latin typeface="Be Vietnam Pro" pitchFamily="34" charset="0"/>
+                <a:ea typeface="Be Vietnam Pro" pitchFamily="34" charset="-122"/>
+                <a:cs typeface="Be Vietnam Pro" pitchFamily="34" charset="-120"/>
+              </a:rPr>
+              <a:t> mới,</a:t>
+            </a:r>
+            <a:r>
+              <a:rPr lang="en-US" sz="3000" b="1" dirty="0" spc="-10" kern="0">
+                <a:solidFill>
+                  <a:srgbClr val="F3EEE3"/>
+                </a:solidFill>
+                <a:latin typeface="Be Vietnam Pro" pitchFamily="34" charset="0"/>
+                <a:ea typeface="Be Vietnam Pro" pitchFamily="34" charset="-122"/>
+                <a:cs typeface="Be Vietnam Pro" pitchFamily="34" charset="-120"/>
+              </a:rPr>
+              <a:t> không</a:t>
+            </a:r>
+            <a:r>
+              <a:rPr lang="en-US" sz="3000" b="1" dirty="0" spc="-2" kern="0">
+                <a:solidFill>
+                  <a:srgbClr val="F3EEE3"/>
+                </a:solidFill>
+                <a:latin typeface="Be Vietnam Pro" pitchFamily="34" charset="0"/>
+                <a:ea typeface="Be Vietnam Pro" pitchFamily="34" charset="-122"/>
+                <a:cs typeface="Be Vietnam Pro" pitchFamily="34" charset="-120"/>
+              </a:rPr>
+              <a:t> thể</a:t>
+            </a:r>
+            <a:r>
+              <a:rPr lang="en-US" sz="3000" b="1" dirty="0" spc="-4" kern="0">
+                <a:solidFill>
+                  <a:srgbClr val="F3EEE3"/>
+                </a:solidFill>
+                <a:latin typeface="Be Vietnam Pro" pitchFamily="34" charset="0"/>
+                <a:ea typeface="Be Vietnam Pro" pitchFamily="34" charset="-122"/>
+                <a:cs typeface="Be Vietnam Pro" pitchFamily="34" charset="-120"/>
+              </a:rPr>
+              <a:t> hiện</a:t>
+            </a:r>
+            <a:r>
+              <a:rPr lang="en-US" sz="3000" b="1" dirty="0" spc="-3" kern="0">
+                <a:solidFill>
+                  <a:srgbClr val="F3EEE3"/>
+                </a:solidFill>
+                <a:latin typeface="Be Vietnam Pro" pitchFamily="34" charset="0"/>
+                <a:ea typeface="Be Vietnam Pro" pitchFamily="34" charset="-122"/>
+                <a:cs typeface="Be Vietnam Pro" pitchFamily="34" charset="-120"/>
+              </a:rPr>
+              <a:t> việc</a:t>
+            </a:r>
+            <a:r>
+              <a:rPr lang="en-US" sz="3000" b="1" dirty="0" spc="-2" kern="0">
+                <a:solidFill>
+                  <a:srgbClr val="F3EEE3"/>
+                </a:solidFill>
+                <a:latin typeface="Be Vietnam Pro" pitchFamily="34" charset="0"/>
+                <a:ea typeface="Be Vietnam Pro" pitchFamily="34" charset="-122"/>
+                <a:cs typeface="Be Vietnam Pro" pitchFamily="34" charset="-120"/>
+              </a:rPr>
+              <a:t> phục</a:t>
+            </a:r>
+            <a:r>
+              <a:rPr lang="en-US" sz="3000" b="1" dirty="0" spc="-4" kern="0">
+                <a:solidFill>
+                  <a:srgbClr val="F3EEE3"/>
+                </a:solidFill>
+                <a:latin typeface="Be Vietnam Pro" pitchFamily="34" charset="0"/>
+                <a:ea typeface="Be Vietnam Pro" pitchFamily="34" charset="-122"/>
+                <a:cs typeface="Be Vietnam Pro" pitchFamily="34" charset="-120"/>
+              </a:rPr>
+              <a:t> hồi</a:t>
+            </a:r>
+            <a:r>
+              <a:rPr lang="en-US" sz="3000" b="1" dirty="0" spc="-11" kern="0">
+                <a:solidFill>
+                  <a:srgbClr val="F3EEE3"/>
+                </a:solidFill>
+                <a:latin typeface="Be Vietnam Pro" pitchFamily="34" charset="0"/>
+                <a:ea typeface="Be Vietnam Pro" pitchFamily="34" charset="-122"/>
+                <a:cs typeface="Be Vietnam Pro" pitchFamily="34" charset="-120"/>
+              </a:rPr>
+              <a:t> công</a:t>
+            </a:r>
+            <a:r>
+              <a:rPr lang="en-US" sz="3000" b="1" dirty="0" spc="-3" kern="0">
+                <a:solidFill>
+                  <a:srgbClr val="F3EEE3"/>
+                </a:solidFill>
+                <a:latin typeface="Be Vietnam Pro" pitchFamily="34" charset="0"/>
+                <a:ea typeface="Be Vietnam Pro" pitchFamily="34" charset="-122"/>
+                <a:cs typeface="Be Vietnam Pro" pitchFamily="34" charset="-120"/>
+              </a:rPr>
+              <a:t> việc</a:t>
+            </a:r>
+            <a:r>
+              <a:rPr lang="en-US" sz="3000" b="1" dirty="0" spc="-2" kern="0">
+                <a:solidFill>
+                  <a:srgbClr val="F3EEE3"/>
+                </a:solidFill>
+                <a:latin typeface="Be Vietnam Pro" pitchFamily="34" charset="0"/>
+                <a:ea typeface="Be Vietnam Pro" pitchFamily="34" charset="-122"/>
+                <a:cs typeface="Be Vietnam Pro" pitchFamily="34" charset="-120"/>
+              </a:rPr>
+              <a:t> A</a:t>
+            </a:r>
+            <a:r>
+              <a:rPr lang="en-US" sz="3000" b="1" dirty="0" spc="3" kern="0">
+                <a:solidFill>
+                  <a:srgbClr val="F3EEE3"/>
+                </a:solidFill>
+                <a:latin typeface="Be Vietnam Pro" pitchFamily="34" charset="0"/>
+                <a:ea typeface="Be Vietnam Pro" pitchFamily="34" charset="-122"/>
+                <a:cs typeface="Be Vietnam Pro" pitchFamily="34" charset="-120"/>
+              </a:rPr>
+              <a:t> đang</a:t>
+            </a:r>
+            <a:r>
+              <a:rPr lang="en-US" sz="3000" b="1" dirty="0" spc="2" kern="0">
+                <a:solidFill>
+                  <a:srgbClr val="F3EEE3"/>
+                </a:solidFill>
+                <a:latin typeface="Be Vietnam Pro" pitchFamily="34" charset="0"/>
+                <a:ea typeface="Be Vietnam Pro" pitchFamily="34" charset="-122"/>
+                <a:cs typeface="Be Vietnam Pro" pitchFamily="34" charset="-120"/>
+              </a:rPr>
+              <a:t> xử lý</a:t>
+            </a:r>
+            <a:r>
+              <a:rPr lang="en-US" sz="3000" b="1" dirty="0" spc="-2" kern="0">
+                <a:solidFill>
+                  <a:srgbClr val="F3EEE3"/>
+                </a:solidFill>
+                <a:latin typeface="Be Vietnam Pro" pitchFamily="34" charset="0"/>
+                <a:ea typeface="Be Vietnam Pro" pitchFamily="34" charset="-122"/>
+                <a:cs typeface="Be Vietnam Pro" pitchFamily="34" charset="-120"/>
+              </a:rPr>
+              <a:t> dở.</a:t>
+            </a:r>
+            <a:endParaRPr lang="en-US" sz="3000" dirty="0"/>
+          </a:p>
+        </p:txBody>
+      </p:sp>
+      <p:sp>
+        <p:nvSpPr>
+          <p:cNvPr id="31" name="Shape 29"/>
           <p:cNvSpPr/>
           <p:nvPr/>
         </p:nvSpPr>
@@ -19910,7 +19371,7 @@
       </p:sp>
       <p:pic>
         <p:nvPicPr>
-          <p:cNvPr id="42" name="Moda image moda-export-watermark-850b2e98-b7cb-4868-a5f8-fadac0d5b286" descr="">    </p:cNvPr>
+          <p:cNvPr id="32" name="Moda image moda-export-watermark-850b2e98-b7cb-4868-a5f8-fadac0d5b286" descr="">    </p:cNvPr>
           <p:cNvPicPr>
             <a:picLocks noChangeAspect="1"/>
           </p:cNvPicPr>

</xml_diff>